<commit_message>
Week 10 pronoun grammar fixed; Despereaux decks W8-16 rebuilt
3.10.01 teacher report: 'She pointed her finger' taught possessive 'her' as an
object pronoun. Replaced in 10.1-10.4 with the verified 'He declared them
outlaws.' Pronouns now marked as the prompt says; reveal explains 'his'.
10.2/9.2 'tap every one' named; 10.3 'underlined' -> slanted letters.

All 36 W8-16 teacher decks rebuilt from current HTML (they still had the old
DOL, old word study, and wrong grammar answers). Extractor/builder now handle
labelled model + fix-it DOL, notice-first grammar (examples, think questions,
pattern), sort games, multi-answer spotters, fill-ins, Day-4 fixes, and Day 2-4
spelling rule slides.

Co-Authored-By: Claude Opus 5.5 <noreply@anthropic.com>
Claude-Session: https://claude.ai/code/session_012bUt32gQ1vQu97CPrY8SmN
</commit_message>
<xml_diff>
--- a/Planning docs/Slides/lesson-13-3-teacher-slides.pptx
+++ b/Planning docs/Slides/lesson-13-3-teacher-slides.pptx
@@ -21,9 +21,11 @@
     <p:sldId id="269" r:id="rId15"/>
     <p:sldId id="270" r:id="rId16"/>
     <p:sldId id="271" r:id="rId17"/>
+    <p:sldId id="272" r:id="rId18"/>
+    <p:sldId id="273" r:id="rId19"/>
   </p:sldIdLst>
   <p:notesMasterIdLst>
-    <p:notesMasterId r:id="rId18"/>
+    <p:notesMasterId r:id="rId20"/>
   </p:notesMasterIdLst>
   <p:sldSz cx="9144000" cy="5143500"/>
   <p:notesSz cx="5143500" cy="9144000"/>
@@ -605,7 +607,7 @@
           <a:p>
             <a:r>
               <a:rPr lang="en-US" dirty="0"/>
-              <a:t>Each word appears in the chapters read this week, in the author’s own sentence.</a:t>
+              <a:t>Break the word into base + word part. Ask what the part adds to the meaning.</a:t>
             </a:r>
             <a:endParaRPr lang="en-US" dirty="0"/>
           </a:p>
@@ -693,7 +695,7 @@
           <a:p>
             <a:r>
               <a:rPr lang="en-US" dirty="0"/>
-              <a:t>Answers: go,”, shouted,, “Gone,”, she?”</a:t>
+              <a:t>Each word appears in the chapters read this week, in the author’s own sentence.</a:t>
             </a:r>
             <a:endParaRPr lang="en-US" dirty="0"/>
           </a:p>
@@ -781,7 +783,8 @@
           <a:p>
             <a:r>
               <a:rPr lang="en-US" dirty="0"/>
-              <a:t>Answers: go,”, shouted,, “Gone,”, she?”</a:t>
+              <a:t>Let students talk through the questions before revealing the pattern.
+Add -er to compare two things. Add -est to compare three or more. So: small, smaller, smallest.</a:t>
             </a:r>
             <a:endParaRPr lang="en-US" dirty="0"/>
           </a:p>
@@ -869,7 +872,8 @@
           <a:p>
             <a:r>
               <a:rPr lang="en-US" dirty="0"/>
-              <a:t>Hard (/k/ or /g/): garlic, gold, candle, Cook | Soft (/s/ or /j/): gentle, magic, prince, mice</a:t>
+              <a:t>Let students talk through the questions before revealing the pattern.
+Add -er to compare two things. Add -est to compare three or more. So: small, smaller, smallest.</a:t>
             </a:r>
             <a:endParaRPr lang="en-US" dirty="0"/>
           </a:p>
@@ -957,7 +961,7 @@
           <a:p>
             <a:r>
               <a:rPr lang="en-US" dirty="0"/>
-              <a:t>Hard (/k/ or /g/): garlic, gold, candle, Cook | Soft (/s/ or /j/): gentle, magic, prince, mice</a:t>
+              <a:t>Answers: smaller, smallest, darker, darkest</a:t>
             </a:r>
             <a:endParaRPr lang="en-US" dirty="0"/>
           </a:p>
@@ -1045,7 +1049,7 @@
           <a:p>
             <a:r>
               <a:rPr lang="en-US" dirty="0"/>
-              <a:t>Read the chapters, then return to the pause questions.</a:t>
+              <a:t>Answers: smaller, smallest, darker, darkest</a:t>
             </a:r>
             <a:endParaRPr lang="en-US" dirty="0"/>
           </a:p>
@@ -1133,7 +1137,7 @@
           <a:p>
             <a:r>
               <a:rPr lang="en-US" dirty="0"/>
-              <a:t>Writer’s Workshop stage for the week.</a:t>
+              <a:t>Rule: A closed syllable ends in a consonant, and that consonant shuts the vowel in so it stays short: nap, kin. Long words are often just two closed syllables stuck together: nap·kin.</a:t>
             </a:r>
             <a:endParaRPr lang="en-US" dirty="0"/>
           </a:p>
@@ -1157,6 +1161,182 @@
             <a:fld id="{F7021451-1387-4CA6-816F-3879F97B5CBC}" type="slidenum">
               <a:rPr lang="en-US"/>
               <a:t>16</a:t>
+            </a:fld>
+            <a:endParaRPr lang="en-US"/>
+          </a:p>
+        </p:txBody>
+      </p:sp>
+    </p:spTree>
+    <p:extLst>
+      <p:ext uri="{BB962C8B-B14F-4D97-AF65-F5344CB8AC3E}">
+        <p14:creationId xmlns:p14="http://schemas.microsoft.com/office/powerpoint/2010/main" val="1024086991"/>
+      </p:ext>
+    </p:extLst>
+  </p:cSld>
+  <p:clrMapOvr>
+    <a:masterClrMapping/>
+  </p:clrMapOvr>
+</p:notes>
+</file>
+
+<file path=ppt/notesSlides/notesSlide17.xml><?xml version="1.0" encoding="utf-8"?>
+<p:notes xmlns:a="http://schemas.openxmlformats.org/drawingml/2006/main" xmlns:r="http://schemas.openxmlformats.org/officeDocument/2006/relationships" xmlns:p="http://schemas.openxmlformats.org/presentationml/2006/main">
+  <p:cSld>
+    <p:spTree>
+      <p:nvGrpSpPr>
+        <p:cNvPr id="1" name=""/>
+        <p:cNvGrpSpPr/>
+        <p:nvPr/>
+      </p:nvGrpSpPr>
+      <p:grpSpPr>
+        <a:xfrm>
+          <a:off x="0" y="0"/>
+          <a:ext cx="0" cy="0"/>
+          <a:chOff x="0" y="0"/>
+          <a:chExt cx="0" cy="0"/>
+        </a:xfrm>
+      </p:grpSpPr>
+      <p:sp>
+        <p:nvSpPr>
+          <p:cNvPr id="2" name="Slide Image Placeholder 1"/>
+          <p:cNvSpPr>
+            <a:spLocks noGrp="1" noRot="1" noChangeAspect="1"/>
+          </p:cNvSpPr>
+          <p:nvPr>
+            <p:ph type="sldImg"/>
+          </p:nvPr>
+        </p:nvSpPr>
+        <p:spPr/>
+      </p:sp>
+      <p:sp>
+        <p:nvSpPr>
+          <p:cNvPr id="3" name="Notes Placeholder 2"/>
+          <p:cNvSpPr>
+            <a:spLocks noGrp="1"/>
+          </p:cNvSpPr>
+          <p:nvPr>
+            <p:ph type="body" idx="1"/>
+          </p:nvPr>
+        </p:nvSpPr>
+        <p:spPr/>
+        <p:txBody>
+          <a:bodyPr/>
+          <a:lstStyle/>
+          <a:p>
+            <a:r>
+              <a:rPr lang="en-US" dirty="0"/>
+              <a:t>Read the chapters, then return to the pause questions.</a:t>
+            </a:r>
+            <a:endParaRPr lang="en-US" dirty="0"/>
+          </a:p>
+        </p:txBody>
+      </p:sp>
+      <p:sp>
+        <p:nvSpPr>
+          <p:cNvPr id="4" name="Slide Number Placeholder 3"/>
+          <p:cNvSpPr>
+            <a:spLocks noGrp="1"/>
+          </p:cNvSpPr>
+          <p:nvPr>
+            <p:ph type="sldNum" sz="quarter" idx="10"/>
+          </p:nvPr>
+        </p:nvSpPr>
+        <p:spPr/>
+        <p:txBody>
+          <a:bodyPr/>
+          <a:lstStyle/>
+          <a:p>
+            <a:fld id="{F7021451-1387-4CA6-816F-3879F97B5CBC}" type="slidenum">
+              <a:rPr lang="en-US"/>
+              <a:t>17</a:t>
+            </a:fld>
+            <a:endParaRPr lang="en-US"/>
+          </a:p>
+        </p:txBody>
+      </p:sp>
+    </p:spTree>
+    <p:extLst>
+      <p:ext uri="{BB962C8B-B14F-4D97-AF65-F5344CB8AC3E}">
+        <p14:creationId xmlns:p14="http://schemas.microsoft.com/office/powerpoint/2010/main" val="1024086991"/>
+      </p:ext>
+    </p:extLst>
+  </p:cSld>
+  <p:clrMapOvr>
+    <a:masterClrMapping/>
+  </p:clrMapOvr>
+</p:notes>
+</file>
+
+<file path=ppt/notesSlides/notesSlide18.xml><?xml version="1.0" encoding="utf-8"?>
+<p:notes xmlns:a="http://schemas.openxmlformats.org/drawingml/2006/main" xmlns:r="http://schemas.openxmlformats.org/officeDocument/2006/relationships" xmlns:p="http://schemas.openxmlformats.org/presentationml/2006/main">
+  <p:cSld>
+    <p:spTree>
+      <p:nvGrpSpPr>
+        <p:cNvPr id="1" name=""/>
+        <p:cNvGrpSpPr/>
+        <p:nvPr/>
+      </p:nvGrpSpPr>
+      <p:grpSpPr>
+        <a:xfrm>
+          <a:off x="0" y="0"/>
+          <a:ext cx="0" cy="0"/>
+          <a:chOff x="0" y="0"/>
+          <a:chExt cx="0" cy="0"/>
+        </a:xfrm>
+      </p:grpSpPr>
+      <p:sp>
+        <p:nvSpPr>
+          <p:cNvPr id="2" name="Slide Image Placeholder 1"/>
+          <p:cNvSpPr>
+            <a:spLocks noGrp="1" noRot="1" noChangeAspect="1"/>
+          </p:cNvSpPr>
+          <p:nvPr>
+            <p:ph type="sldImg"/>
+          </p:nvPr>
+        </p:nvSpPr>
+        <p:spPr/>
+      </p:sp>
+      <p:sp>
+        <p:nvSpPr>
+          <p:cNvPr id="3" name="Notes Placeholder 2"/>
+          <p:cNvSpPr>
+            <a:spLocks noGrp="1"/>
+          </p:cNvSpPr>
+          <p:nvPr>
+            <p:ph type="body" idx="1"/>
+          </p:nvPr>
+        </p:nvSpPr>
+        <p:spPr/>
+        <p:txBody>
+          <a:bodyPr/>
+          <a:lstStyle/>
+          <a:p>
+            <a:r>
+              <a:rPr lang="en-US" dirty="0"/>
+              <a:t>Writer’s Workshop stage for the week.</a:t>
+            </a:r>
+            <a:endParaRPr lang="en-US" dirty="0"/>
+          </a:p>
+        </p:txBody>
+      </p:sp>
+      <p:sp>
+        <p:nvSpPr>
+          <p:cNvPr id="4" name="Slide Number Placeholder 3"/>
+          <p:cNvSpPr>
+            <a:spLocks noGrp="1"/>
+          </p:cNvSpPr>
+          <p:nvPr>
+            <p:ph type="sldNum" sz="quarter" idx="10"/>
+          </p:nvPr>
+        </p:nvSpPr>
+        <p:spPr/>
+        <p:txBody>
+          <a:bodyPr/>
+          <a:lstStyle/>
+          <a:p>
+            <a:fld id="{F7021451-1387-4CA6-816F-3879F97B5CBC}" type="slidenum">
+              <a:rPr lang="en-US"/>
+              <a:t>18</a:t>
             </a:fld>
             <a:endParaRPr lang="en-US"/>
           </a:p>
@@ -1573,7 +1753,7 @@
           <a:p>
             <a:r>
               <a:rPr lang="en-US" dirty="0"/>
-              <a:t>Reading lens: Good readers look for theme clues . A theme is a lesson the whole story teaches.</a:t>
+              <a:t>Reading lens: Good readers look for theme clues. A theme is a lesson the whole story teaches.</a:t>
             </a:r>
             <a:endParaRPr lang="en-US" dirty="0"/>
           </a:p>
@@ -1661,8 +1841,7 @@
           <a:p>
             <a:r>
               <a:rPr lang="en-US" dirty="0"/>
-              <a:t>Corrected:  1. Miggery Sow was sent away from the castle , but she was not sent away unkindly or cruelly.
-Look for: Did you catch the proper nouns (Miggery Sow), the -ly adverbs (unkindly, cruelly, slowly, carefully), and the comma before "but"?</a:t>
+              <a:t>Tap through each highlighted word in the lesson and name what it does right before moving to the fix-it.</a:t>
             </a:r>
             <a:endParaRPr lang="en-US" dirty="0"/>
           </a:p>
@@ -1750,8 +1929,8 @@
           <a:p>
             <a:r>
               <a:rPr lang="en-US" dirty="0"/>
-              <a:t>Corrected:  1. Miggery Sow was sent away from the castle , but she was not sent away unkindly or cruelly.
-Look for: Did you catch the proper nouns (Miggery Sow), the -ly adverbs (unkindly, cruelly, slowly, carefully), and the comma before "but"?</a:t>
+              <a:t>Corrected: Miggery Sow was sent away from the castle, but she was not sent away unkindly or cruelly. 
+Look for: </a:t>
             </a:r>
             <a:endParaRPr lang="en-US" dirty="0"/>
           </a:p>
@@ -1839,7 +2018,8 @@
           <a:p>
             <a:r>
               <a:rPr lang="en-US" dirty="0"/>
-              <a:t>Break the word into base + word part. Ask what the part adds to the meaning.</a:t>
+              <a:t>Corrected: Miggery Sow was sent away from the castle, but she was not sent away unkindly or cruelly. 
+Look for: </a:t>
             </a:r>
             <a:endParaRPr lang="en-US" dirty="0"/>
           </a:p>
@@ -2412,7 +2592,7 @@
             <a:avLst/>
           </a:prstGeom>
           <a:solidFill>
-            <a:srgbClr val="55C8E8"/>
+            <a:srgbClr val="8B6FC0"/>
           </a:solidFill>
           <a:ln/>
         </p:spPr>
@@ -2450,7 +2630,7 @@
                 <a:ea typeface="Calibri" pitchFamily="34" charset="-122"/>
                 <a:cs typeface="Calibri" pitchFamily="34" charset="-120"/>
               </a:rPr>
-              <a:t>🔤  Vocabulary</a:t>
+              <a:t>🌱  Morphology</a:t>
             </a:r>
             <a:endParaRPr lang="en-US" sz="2200" dirty="0"/>
           </a:p>
@@ -2483,13 +2663,13 @@
             <a:r>
               <a:rPr lang="en-US" sz="1100" b="1" spc="100" kern="0" dirty="0">
                 <a:solidFill>
-                  <a:srgbClr val="55C8E8"/>
-                </a:solidFill>
-                <a:latin typeface="Calibri" pitchFamily="34" charset="0"/>
-                <a:ea typeface="Calibri" pitchFamily="34" charset="-122"/>
-                <a:cs typeface="Calibri" pitchFamily="34" charset="-120"/>
-              </a:rPr>
-              <a:t>VOCABULARY</a:t>
+                  <a:srgbClr val="8B6FC0"/>
+                </a:solidFill>
+                <a:latin typeface="Calibri" pitchFamily="34" charset="0"/>
+                <a:ea typeface="Calibri" pitchFamily="34" charset="-122"/>
+                <a:cs typeface="Calibri" pitchFamily="34" charset="-120"/>
+              </a:rPr>
+              <a:t>NON-</a:t>
             </a:r>
             <a:endParaRPr lang="en-US" sz="1100" dirty="0"/>
           </a:p>
@@ -2504,15 +2684,15 @@
         <p:spPr>
           <a:xfrm>
             <a:off x="365760" y="1097280"/>
-            <a:ext cx="8412480" cy="658368"/>
+            <a:ext cx="8412480" cy="621792"/>
           </a:xfrm>
           <a:prstGeom prst="roundRect">
             <a:avLst>
-              <a:gd name="adj" fmla="val 13889"/>
+              <a:gd name="adj" fmla="val 14706"/>
             </a:avLst>
           </a:prstGeom>
           <a:solidFill>
-            <a:srgbClr val="E5F7FC"/>
+            <a:srgbClr val="F0E8FF"/>
           </a:solidFill>
           <a:ln/>
           <a:effectLst>
@@ -2532,38 +2712,24 @@
         </p:nvSpPr>
         <p:spPr>
           <a:xfrm>
-            <a:off x="594360" y="1225296"/>
-            <a:ext cx="7863840" cy="420624"/>
-          </a:xfrm>
-          <a:prstGeom prst="rect">
-            <a:avLst/>
-          </a:prstGeom>
-          <a:noFill/>
-          <a:ln/>
-        </p:spPr>
-        <p:txBody>
-          <a:bodyPr wrap="square" lIns="0" tIns="0" rIns="0" bIns="0" rtlCol="0" anchor="ctr"/>
-          <a:lstStyle/>
-          <a:p>
-            <a:pPr indent="0" marL="0">
-              <a:buNone/>
-            </a:pPr>
-            <a:r>
-              <a:rPr lang="en-US" sz="1700" b="1" dirty="0">
-                <a:solidFill>
-                  <a:srgbClr val="0E1C42"/>
-                </a:solidFill>
-                <a:latin typeface="Calibri" pitchFamily="34" charset="0"/>
-                <a:ea typeface="Calibri" pitchFamily="34" charset="-122"/>
-                <a:cs typeface="Calibri" pitchFamily="34" charset="-120"/>
-              </a:rPr>
-              <a:t>needle  </a:t>
-            </a:r>
-            <a:pPr indent="0" marL="0">
-              <a:buNone/>
-            </a:pPr>
-            <a:r>
-              <a:rPr lang="en-US" sz="1400" dirty="0">
+            <a:off x="594360" y="1216152"/>
+            <a:ext cx="7863840" cy="384048"/>
+          </a:xfrm>
+          <a:prstGeom prst="rect">
+            <a:avLst/>
+          </a:prstGeom>
+          <a:noFill/>
+          <a:ln/>
+        </p:spPr>
+        <p:txBody>
+          <a:bodyPr wrap="square" lIns="0" tIns="0" rIns="0" bIns="0" rtlCol="0" anchor="ctr"/>
+          <a:lstStyle/>
+          <a:p>
+            <a:pPr indent="0" marL="0">
+              <a:buNone/>
+            </a:pPr>
+            <a:r>
+              <a:rPr lang="en-US" sz="1500" dirty="0">
                 <a:solidFill>
                   <a:srgbClr val="1E293B"/>
                 </a:solidFill>
@@ -2571,9 +2737,9 @@
                 <a:ea typeface="Calibri" pitchFamily="34" charset="-122"/>
                 <a:cs typeface="Calibri" pitchFamily="34" charset="-120"/>
               </a:rPr>
-              <a:t>A thin, sharp metal tool for sewing — here, a mouse's sword.</a:t>
-            </a:r>
-            <a:endParaRPr lang="en-US" sz="1700" dirty="0"/>
+              <a:t>🌱  non- + fiction →nonfiction — writing that is not made up</a:t>
+            </a:r>
+            <a:endParaRPr lang="en-US" sz="1500" dirty="0"/>
           </a:p>
         </p:txBody>
       </p:sp>
@@ -2585,16 +2751,16 @@
         </p:nvSpPr>
         <p:spPr>
           <a:xfrm>
-            <a:off x="365760" y="1828800"/>
-            <a:ext cx="8412480" cy="658368"/>
+            <a:off x="365760" y="1792224"/>
+            <a:ext cx="8412480" cy="621792"/>
           </a:xfrm>
           <a:prstGeom prst="roundRect">
             <a:avLst>
-              <a:gd name="adj" fmla="val 13889"/>
+              <a:gd name="adj" fmla="val 14706"/>
             </a:avLst>
           </a:prstGeom>
           <a:solidFill>
-            <a:srgbClr val="FFFFFF"/>
+            <a:srgbClr val="F8F4FF"/>
           </a:solidFill>
           <a:ln/>
           <a:effectLst>
@@ -2614,38 +2780,24 @@
         </p:nvSpPr>
         <p:spPr>
           <a:xfrm>
-            <a:off x="594360" y="1956816"/>
-            <a:ext cx="7863840" cy="420624"/>
-          </a:xfrm>
-          <a:prstGeom prst="rect">
-            <a:avLst/>
-          </a:prstGeom>
-          <a:noFill/>
-          <a:ln/>
-        </p:spPr>
-        <p:txBody>
-          <a:bodyPr wrap="square" lIns="0" tIns="0" rIns="0" bIns="0" rtlCol="0" anchor="ctr"/>
-          <a:lstStyle/>
-          <a:p>
-            <a:pPr indent="0" marL="0">
-              <a:buNone/>
-            </a:pPr>
-            <a:r>
-              <a:rPr lang="en-US" sz="1700" b="1" dirty="0">
-                <a:solidFill>
-                  <a:srgbClr val="0E1C42"/>
-                </a:solidFill>
-                <a:latin typeface="Calibri" pitchFamily="34" charset="0"/>
-                <a:ea typeface="Calibri" pitchFamily="34" charset="-122"/>
-                <a:cs typeface="Calibri" pitchFamily="34" charset="-120"/>
-              </a:rPr>
-              <a:t>forgiven  </a:t>
-            </a:r>
-            <a:pPr indent="0" marL="0">
-              <a:buNone/>
-            </a:pPr>
-            <a:r>
-              <a:rPr lang="en-US" sz="1400" dirty="0">
+            <a:off x="594360" y="1911096"/>
+            <a:ext cx="7863840" cy="384048"/>
+          </a:xfrm>
+          <a:prstGeom prst="rect">
+            <a:avLst/>
+          </a:prstGeom>
+          <a:noFill/>
+          <a:ln/>
+        </p:spPr>
+        <p:txBody>
+          <a:bodyPr wrap="square" lIns="0" tIns="0" rIns="0" bIns="0" rtlCol="0" anchor="ctr"/>
+          <a:lstStyle/>
+          <a:p>
+            <a:pPr indent="0" marL="0">
+              <a:buNone/>
+            </a:pPr>
+            <a:r>
+              <a:rPr lang="en-US" sz="1500" dirty="0">
                 <a:solidFill>
                   <a:srgbClr val="1E293B"/>
                 </a:solidFill>
@@ -2653,9 +2805,9 @@
                 <a:ea typeface="Calibri" pitchFamily="34" charset="-122"/>
                 <a:cs typeface="Calibri" pitchFamily="34" charset="-120"/>
               </a:rPr>
-              <a:t>No longer blamed for something you did wrong.</a:t>
-            </a:r>
-            <a:endParaRPr lang="en-US" sz="1700" dirty="0"/>
+              <a:t>🌱  non- + sense →nonsense — words that do not make sense</a:t>
+            </a:r>
+            <a:endParaRPr lang="en-US" sz="1500" dirty="0"/>
           </a:p>
         </p:txBody>
       </p:sp>
@@ -2667,16 +2819,16 @@
         </p:nvSpPr>
         <p:spPr>
           <a:xfrm>
-            <a:off x="365760" y="2560320"/>
-            <a:ext cx="8412480" cy="658368"/>
+            <a:off x="365760" y="2487168"/>
+            <a:ext cx="8412480" cy="621792"/>
           </a:xfrm>
           <a:prstGeom prst="roundRect">
             <a:avLst>
-              <a:gd name="adj" fmla="val 13889"/>
+              <a:gd name="adj" fmla="val 14706"/>
             </a:avLst>
           </a:prstGeom>
           <a:solidFill>
-            <a:srgbClr val="E5F7FC"/>
+            <a:srgbClr val="F0E8FF"/>
           </a:solidFill>
           <a:ln/>
           <a:effectLst>
@@ -2696,38 +2848,24 @@
         </p:nvSpPr>
         <p:spPr>
           <a:xfrm>
-            <a:off x="594360" y="2688336"/>
-            <a:ext cx="7863840" cy="420624"/>
-          </a:xfrm>
-          <a:prstGeom prst="rect">
-            <a:avLst/>
-          </a:prstGeom>
-          <a:noFill/>
-          <a:ln/>
-        </p:spPr>
-        <p:txBody>
-          <a:bodyPr wrap="square" lIns="0" tIns="0" rIns="0" bIns="0" rtlCol="0" anchor="ctr"/>
-          <a:lstStyle/>
-          <a:p>
-            <a:pPr indent="0" marL="0">
-              <a:buNone/>
-            </a:pPr>
-            <a:r>
-              <a:rPr lang="en-US" sz="1700" b="1" dirty="0">
-                <a:solidFill>
-                  <a:srgbClr val="0E1C42"/>
-                </a:solidFill>
-                <a:latin typeface="Calibri" pitchFamily="34" charset="0"/>
-                <a:ea typeface="Calibri" pitchFamily="34" charset="-122"/>
-                <a:cs typeface="Calibri" pitchFamily="34" charset="-120"/>
-              </a:rPr>
-              <a:t>braver  </a:t>
-            </a:r>
-            <a:pPr indent="0" marL="0">
-              <a:buNone/>
-            </a:pPr>
-            <a:r>
-              <a:rPr lang="en-US" sz="1400" dirty="0">
+            <a:off x="594360" y="2606040"/>
+            <a:ext cx="7863840" cy="384048"/>
+          </a:xfrm>
+          <a:prstGeom prst="rect">
+            <a:avLst/>
+          </a:prstGeom>
+          <a:noFill/>
+          <a:ln/>
+        </p:spPr>
+        <p:txBody>
+          <a:bodyPr wrap="square" lIns="0" tIns="0" rIns="0" bIns="0" rtlCol="0" anchor="ctr"/>
+          <a:lstStyle/>
+          <a:p>
+            <a:pPr indent="0" marL="0">
+              <a:buNone/>
+            </a:pPr>
+            <a:r>
+              <a:rPr lang="en-US" sz="1500" dirty="0">
                 <a:solidFill>
                   <a:srgbClr val="1E293B"/>
                 </a:solidFill>
@@ -2735,9 +2873,9 @@
                 <a:ea typeface="Calibri" pitchFamily="34" charset="-122"/>
                 <a:cs typeface="Calibri" pitchFamily="34" charset="-120"/>
               </a:rPr>
-              <a:t>More willing to face something frightening.</a:t>
-            </a:r>
-            <a:endParaRPr lang="en-US" sz="1700" dirty="0"/>
+              <a:t>🌱  non- + stop →nonstop — without stopping</a:t>
+            </a:r>
+            <a:endParaRPr lang="en-US" sz="1500" dirty="0"/>
           </a:p>
         </p:txBody>
       </p:sp>
@@ -2749,16 +2887,16 @@
         </p:nvSpPr>
         <p:spPr>
           <a:xfrm>
-            <a:off x="365760" y="3291840"/>
-            <a:ext cx="8412480" cy="658368"/>
+            <a:off x="365760" y="3182112"/>
+            <a:ext cx="8412480" cy="621792"/>
           </a:xfrm>
           <a:prstGeom prst="roundRect">
             <a:avLst>
-              <a:gd name="adj" fmla="val 13889"/>
+              <a:gd name="adj" fmla="val 14706"/>
             </a:avLst>
           </a:prstGeom>
           <a:solidFill>
-            <a:srgbClr val="FFFFFF"/>
+            <a:srgbClr val="F8F4FF"/>
           </a:solidFill>
           <a:ln/>
           <a:effectLst>
@@ -2778,38 +2916,24 @@
         </p:nvSpPr>
         <p:spPr>
           <a:xfrm>
-            <a:off x="594360" y="3419856"/>
-            <a:ext cx="7863840" cy="420624"/>
-          </a:xfrm>
-          <a:prstGeom prst="rect">
-            <a:avLst/>
-          </a:prstGeom>
-          <a:noFill/>
-          <a:ln/>
-        </p:spPr>
-        <p:txBody>
-          <a:bodyPr wrap="square" lIns="0" tIns="0" rIns="0" bIns="0" rtlCol="0" anchor="ctr"/>
-          <a:lstStyle/>
-          <a:p>
-            <a:pPr indent="0" marL="0">
-              <a:buNone/>
-            </a:pPr>
-            <a:r>
-              <a:rPr lang="en-US" sz="1700" b="1" dirty="0">
-                <a:solidFill>
-                  <a:srgbClr val="0E1C42"/>
-                </a:solidFill>
-                <a:latin typeface="Calibri" pitchFamily="34" charset="0"/>
-                <a:ea typeface="Calibri" pitchFamily="34" charset="-122"/>
-                <a:cs typeface="Calibri" pitchFamily="34" charset="-120"/>
-              </a:rPr>
-              <a:t>crown  </a:t>
-            </a:r>
-            <a:pPr indent="0" marL="0">
-              <a:buNone/>
-            </a:pPr>
-            <a:r>
-              <a:rPr lang="en-US" sz="1400" dirty="0">
+            <a:off x="594360" y="3300984"/>
+            <a:ext cx="7863840" cy="384048"/>
+          </a:xfrm>
+          <a:prstGeom prst="rect">
+            <a:avLst/>
+          </a:prstGeom>
+          <a:noFill/>
+          <a:ln/>
+        </p:spPr>
+        <p:txBody>
+          <a:bodyPr wrap="square" lIns="0" tIns="0" rIns="0" bIns="0" rtlCol="0" anchor="ctr"/>
+          <a:lstStyle/>
+          <a:p>
+            <a:pPr indent="0" marL="0">
+              <a:buNone/>
+            </a:pPr>
+            <a:r>
+              <a:rPr lang="en-US" sz="1500" dirty="0">
                 <a:solidFill>
                   <a:srgbClr val="1E293B"/>
                 </a:solidFill>
@@ -2817,9 +2941,9 @@
                 <a:ea typeface="Calibri" pitchFamily="34" charset="-122"/>
                 <a:cs typeface="Calibri" pitchFamily="34" charset="-120"/>
               </a:rPr>
-              <a:t>The circle of gold and jewels a king or queen wears.</a:t>
-            </a:r>
-            <a:endParaRPr lang="en-US" sz="1700" dirty="0"/>
+              <a:t>🌱  non- + living →nonliving — not alive</a:t>
+            </a:r>
+            <a:endParaRPr lang="en-US" sz="1500" dirty="0"/>
           </a:p>
         </p:txBody>
       </p:sp>
@@ -2837,7 +2961,7 @@
     <p:bg>
       <p:bgPr>
         <a:solidFill>
-          <a:srgbClr val="F8FAFC"/>
+          <a:srgbClr val="FFFFFF"/>
         </a:solidFill>
       </p:bgPr>
     </p:bg>
@@ -2870,7 +2994,7 @@
             <a:avLst/>
           </a:prstGeom>
           <a:solidFill>
-            <a:srgbClr val="C7922C"/>
+            <a:srgbClr val="55C8E8"/>
           </a:solidFill>
           <a:ln/>
         </p:spPr>
@@ -2908,7 +3032,7 @@
                 <a:ea typeface="Calibri" pitchFamily="34" charset="-122"/>
                 <a:cs typeface="Calibri" pitchFamily="34" charset="-120"/>
               </a:rPr>
-              <a:t>✏️  Grammar</a:t>
+              <a:t>🔤  Vocabulary</a:t>
             </a:r>
             <a:endParaRPr lang="en-US" sz="2200" dirty="0"/>
           </a:p>
@@ -2922,7 +3046,7 @@
         </p:nvSpPr>
         <p:spPr>
           <a:xfrm>
-            <a:off x="365760" y="777240"/>
+            <a:off x="365760" y="804672"/>
             <a:ext cx="8229600" cy="237744"/>
           </a:xfrm>
           <a:prstGeom prst="rect">
@@ -2941,13 +3065,13 @@
             <a:r>
               <a:rPr lang="en-US" sz="1100" b="1" spc="100" kern="0" dirty="0">
                 <a:solidFill>
-                  <a:srgbClr val="C7922C"/>
-                </a:solidFill>
-                <a:latin typeface="Calibri" pitchFamily="34" charset="0"/>
-                <a:ea typeface="Calibri" pitchFamily="34" charset="-122"/>
-                <a:cs typeface="Calibri" pitchFamily="34" charset="-120"/>
-              </a:rPr>
-              <a:t>DIALOGUE: PUTTING IT TO WORK</a:t>
+                  <a:srgbClr val="55C8E8"/>
+                </a:solidFill>
+                <a:latin typeface="Calibri" pitchFamily="34" charset="0"/>
+                <a:ea typeface="Calibri" pitchFamily="34" charset="-122"/>
+                <a:cs typeface="Calibri" pitchFamily="34" charset="-120"/>
+              </a:rPr>
+              <a:t>VOCABULARY</a:t>
             </a:r>
             <a:endParaRPr lang="en-US" sz="1100" dirty="0"/>
           </a:p>
@@ -2961,7 +3085,7 @@
         </p:nvSpPr>
         <p:spPr>
           <a:xfrm>
-            <a:off x="365760" y="1078992"/>
+            <a:off x="365760" y="1097280"/>
             <a:ext cx="8412480" cy="658368"/>
           </a:xfrm>
           <a:prstGeom prst="roundRect">
@@ -2970,7 +3094,7 @@
             </a:avLst>
           </a:prstGeom>
           <a:solidFill>
-            <a:srgbClr val="FEF6E8"/>
+            <a:srgbClr val="E5F7FC"/>
           </a:solidFill>
           <a:ln/>
           <a:effectLst>
@@ -2991,23 +3115,37 @@
         <p:spPr>
           <a:xfrm>
             <a:off x="594360" y="1225296"/>
-            <a:ext cx="7863840" cy="402336"/>
-          </a:xfrm>
-          <a:prstGeom prst="rect">
-            <a:avLst/>
-          </a:prstGeom>
-          <a:noFill/>
-          <a:ln/>
-        </p:spPr>
-        <p:txBody>
-          <a:bodyPr wrap="square" lIns="0" tIns="0" rIns="0" bIns="0" rtlCol="0" anchor="ctr"/>
-          <a:lstStyle/>
-          <a:p>
-            <a:pPr indent="0" marL="0">
-              <a:buNone/>
-            </a:pPr>
-            <a:r>
-              <a:rPr lang="en-US" sz="1600" dirty="0">
+            <a:ext cx="7863840" cy="420624"/>
+          </a:xfrm>
+          <a:prstGeom prst="rect">
+            <a:avLst/>
+          </a:prstGeom>
+          <a:noFill/>
+          <a:ln/>
+        </p:spPr>
+        <p:txBody>
+          <a:bodyPr wrap="square" lIns="0" tIns="0" rIns="0" bIns="0" rtlCol="0" anchor="ctr"/>
+          <a:lstStyle/>
+          <a:p>
+            <a:pPr indent="0" marL="0">
+              <a:buNone/>
+            </a:pPr>
+            <a:r>
+              <a:rPr lang="en-US" sz="1700" b="1" dirty="0">
+                <a:solidFill>
+                  <a:srgbClr val="0E1C42"/>
+                </a:solidFill>
+                <a:latin typeface="Calibri" pitchFamily="34" charset="0"/>
+                <a:ea typeface="Calibri" pitchFamily="34" charset="-122"/>
+                <a:cs typeface="Calibri" pitchFamily="34" charset="-120"/>
+              </a:rPr>
+              <a:t>needle  </a:t>
+            </a:r>
+            <a:pPr indent="0" marL="0">
+              <a:buNone/>
+            </a:pPr>
+            <a:r>
+              <a:rPr lang="en-US" sz="1400" dirty="0">
                 <a:solidFill>
                   <a:srgbClr val="1E293B"/>
                 </a:solidFill>
@@ -3015,9 +3153,9 @@
                 <a:ea typeface="Calibri" pitchFamily="34" charset="-122"/>
                 <a:cs typeface="Calibri" pitchFamily="34" charset="-120"/>
               </a:rPr>
-              <a:t>“I will go,” said the mouse.</a:t>
-            </a:r>
-            <a:endParaRPr lang="en-US" sz="1600" dirty="0"/>
+              <a:t>A thin, sharp metal tool for sewing — here, a mouse's sword.</a:t>
+            </a:r>
+            <a:endParaRPr lang="en-US" sz="1700" dirty="0"/>
           </a:p>
         </p:txBody>
       </p:sp>
@@ -3029,7 +3167,7 @@
         </p:nvSpPr>
         <p:spPr>
           <a:xfrm>
-            <a:off x="365760" y="1810512"/>
+            <a:off x="365760" y="1828800"/>
             <a:ext cx="8412480" cy="658368"/>
           </a:xfrm>
           <a:prstGeom prst="roundRect">
@@ -3059,23 +3197,37 @@
         <p:spPr>
           <a:xfrm>
             <a:off x="594360" y="1956816"/>
-            <a:ext cx="7863840" cy="402336"/>
-          </a:xfrm>
-          <a:prstGeom prst="rect">
-            <a:avLst/>
-          </a:prstGeom>
-          <a:noFill/>
-          <a:ln/>
-        </p:spPr>
-        <p:txBody>
-          <a:bodyPr wrap="square" lIns="0" tIns="0" rIns="0" bIns="0" rtlCol="0" anchor="ctr"/>
-          <a:lstStyle/>
-          <a:p>
-            <a:pPr indent="0" marL="0">
-              <a:buNone/>
-            </a:pPr>
-            <a:r>
-              <a:rPr lang="en-US" sz="1600" dirty="0">
+            <a:ext cx="7863840" cy="420624"/>
+          </a:xfrm>
+          <a:prstGeom prst="rect">
+            <a:avLst/>
+          </a:prstGeom>
+          <a:noFill/>
+          <a:ln/>
+        </p:spPr>
+        <p:txBody>
+          <a:bodyPr wrap="square" lIns="0" tIns="0" rIns="0" bIns="0" rtlCol="0" anchor="ctr"/>
+          <a:lstStyle/>
+          <a:p>
+            <a:pPr indent="0" marL="0">
+              <a:buNone/>
+            </a:pPr>
+            <a:r>
+              <a:rPr lang="en-US" sz="1700" b="1" dirty="0">
+                <a:solidFill>
+                  <a:srgbClr val="0E1C42"/>
+                </a:solidFill>
+                <a:latin typeface="Calibri" pitchFamily="34" charset="0"/>
+                <a:ea typeface="Calibri" pitchFamily="34" charset="-122"/>
+                <a:cs typeface="Calibri" pitchFamily="34" charset="-120"/>
+              </a:rPr>
+              <a:t>forgiven  </a:t>
+            </a:r>
+            <a:pPr indent="0" marL="0">
+              <a:buNone/>
+            </a:pPr>
+            <a:r>
+              <a:rPr lang="en-US" sz="1400" dirty="0">
                 <a:solidFill>
                   <a:srgbClr val="1E293B"/>
                 </a:solidFill>
@@ -3083,9 +3235,9 @@
                 <a:ea typeface="Calibri" pitchFamily="34" charset="-122"/>
                 <a:cs typeface="Calibri" pitchFamily="34" charset="-120"/>
               </a:rPr>
-              <a:t>The king shouted, “Find her!”</a:t>
-            </a:r>
-            <a:endParaRPr lang="en-US" sz="1600" dirty="0"/>
+              <a:t>No longer blamed for something you did wrong.</a:t>
+            </a:r>
+            <a:endParaRPr lang="en-US" sz="1700" dirty="0"/>
           </a:p>
         </p:txBody>
       </p:sp>
@@ -3097,7 +3249,7 @@
         </p:nvSpPr>
         <p:spPr>
           <a:xfrm>
-            <a:off x="365760" y="2542032"/>
+            <a:off x="365760" y="2560320"/>
             <a:ext cx="8412480" cy="658368"/>
           </a:xfrm>
           <a:prstGeom prst="roundRect">
@@ -3106,7 +3258,7 @@
             </a:avLst>
           </a:prstGeom>
           <a:solidFill>
-            <a:srgbClr val="FEF6E8"/>
+            <a:srgbClr val="E5F7FC"/>
           </a:solidFill>
           <a:ln/>
           <a:effectLst>
@@ -3127,23 +3279,37 @@
         <p:spPr>
           <a:xfrm>
             <a:off x="594360" y="2688336"/>
-            <a:ext cx="7863840" cy="402336"/>
-          </a:xfrm>
-          <a:prstGeom prst="rect">
-            <a:avLst/>
-          </a:prstGeom>
-          <a:noFill/>
-          <a:ln/>
-        </p:spPr>
-        <p:txBody>
-          <a:bodyPr wrap="square" lIns="0" tIns="0" rIns="0" bIns="0" rtlCol="0" anchor="ctr"/>
-          <a:lstStyle/>
-          <a:p>
-            <a:pPr indent="0" marL="0">
-              <a:buNone/>
-            </a:pPr>
-            <a:r>
-              <a:rPr lang="en-US" sz="1600" dirty="0">
+            <a:ext cx="7863840" cy="420624"/>
+          </a:xfrm>
+          <a:prstGeom prst="rect">
+            <a:avLst/>
+          </a:prstGeom>
+          <a:noFill/>
+          <a:ln/>
+        </p:spPr>
+        <p:txBody>
+          <a:bodyPr wrap="square" lIns="0" tIns="0" rIns="0" bIns="0" rtlCol="0" anchor="ctr"/>
+          <a:lstStyle/>
+          <a:p>
+            <a:pPr indent="0" marL="0">
+              <a:buNone/>
+            </a:pPr>
+            <a:r>
+              <a:rPr lang="en-US" sz="1700" b="1" dirty="0">
+                <a:solidFill>
+                  <a:srgbClr val="0E1C42"/>
+                </a:solidFill>
+                <a:latin typeface="Calibri" pitchFamily="34" charset="0"/>
+                <a:ea typeface="Calibri" pitchFamily="34" charset="-122"/>
+                <a:cs typeface="Calibri" pitchFamily="34" charset="-120"/>
+              </a:rPr>
+              <a:t>braver  </a:t>
+            </a:r>
+            <a:pPr indent="0" marL="0">
+              <a:buNone/>
+            </a:pPr>
+            <a:r>
+              <a:rPr lang="en-US" sz="1400" dirty="0">
                 <a:solidFill>
                   <a:srgbClr val="1E293B"/>
                 </a:solidFill>
@@ -3151,9 +3317,9 @@
                 <a:ea typeface="Calibri" pitchFamily="34" charset="-122"/>
                 <a:cs typeface="Calibri" pitchFamily="34" charset="-120"/>
               </a:rPr>
-              <a:t>“Gone,” said Cook quietly.</a:t>
-            </a:r>
-            <a:endParaRPr lang="en-US" sz="1600" dirty="0"/>
+              <a:t>More willing to face something frightening.</a:t>
+            </a:r>
+            <a:endParaRPr lang="en-US" sz="1700" dirty="0"/>
           </a:p>
         </p:txBody>
       </p:sp>
@@ -3165,7 +3331,7 @@
         </p:nvSpPr>
         <p:spPr>
           <a:xfrm>
-            <a:off x="365760" y="3273552"/>
+            <a:off x="365760" y="3291840"/>
             <a:ext cx="8412480" cy="658368"/>
           </a:xfrm>
           <a:prstGeom prst="roundRect">
@@ -3195,23 +3361,37 @@
         <p:spPr>
           <a:xfrm>
             <a:off x="594360" y="3419856"/>
-            <a:ext cx="7863840" cy="402336"/>
-          </a:xfrm>
-          <a:prstGeom prst="rect">
-            <a:avLst/>
-          </a:prstGeom>
-          <a:noFill/>
-          <a:ln/>
-        </p:spPr>
-        <p:txBody>
-          <a:bodyPr wrap="square" lIns="0" tIns="0" rIns="0" bIns="0" rtlCol="0" anchor="ctr"/>
-          <a:lstStyle/>
-          <a:p>
-            <a:pPr indent="0" marL="0">
-              <a:buNone/>
-            </a:pPr>
-            <a:r>
-              <a:rPr lang="en-US" sz="1600" dirty="0">
+            <a:ext cx="7863840" cy="420624"/>
+          </a:xfrm>
+          <a:prstGeom prst="rect">
+            <a:avLst/>
+          </a:prstGeom>
+          <a:noFill/>
+          <a:ln/>
+        </p:spPr>
+        <p:txBody>
+          <a:bodyPr wrap="square" lIns="0" tIns="0" rIns="0" bIns="0" rtlCol="0" anchor="ctr"/>
+          <a:lstStyle/>
+          <a:p>
+            <a:pPr indent="0" marL="0">
+              <a:buNone/>
+            </a:pPr>
+            <a:r>
+              <a:rPr lang="en-US" sz="1700" b="1" dirty="0">
+                <a:solidFill>
+                  <a:srgbClr val="0E1C42"/>
+                </a:solidFill>
+                <a:latin typeface="Calibri" pitchFamily="34" charset="0"/>
+                <a:ea typeface="Calibri" pitchFamily="34" charset="-122"/>
+                <a:cs typeface="Calibri" pitchFamily="34" charset="-120"/>
+              </a:rPr>
+              <a:t>crown  </a:t>
+            </a:r>
+            <a:pPr indent="0" marL="0">
+              <a:buNone/>
+            </a:pPr>
+            <a:r>
+              <a:rPr lang="en-US" sz="1400" dirty="0">
                 <a:solidFill>
                   <a:srgbClr val="1E293B"/>
                 </a:solidFill>
@@ -3219,48 +3399,9 @@
                 <a:ea typeface="Calibri" pitchFamily="34" charset="-122"/>
                 <a:cs typeface="Calibri" pitchFamily="34" charset="-120"/>
               </a:rPr>
-              <a:t>“Where is she?” asked Despereaux.</a:t>
-            </a:r>
-            <a:endParaRPr lang="en-US" sz="1600" dirty="0"/>
-          </a:p>
-        </p:txBody>
-      </p:sp>
-      <p:sp>
-        <p:nvSpPr>
-          <p:cNvPr id="13" name="Text 11"/>
-          <p:cNvSpPr/>
-          <p:nvPr/>
-        </p:nvSpPr>
-        <p:spPr>
-          <a:xfrm>
-            <a:off x="365760" y="4050792"/>
-            <a:ext cx="8412480" cy="365760"/>
-          </a:xfrm>
-          <a:prstGeom prst="rect">
-            <a:avLst/>
-          </a:prstGeom>
-          <a:noFill/>
-          <a:ln/>
-        </p:spPr>
-        <p:txBody>
-          <a:bodyPr wrap="square" lIns="0" tIns="0" rIns="0" bIns="0" rtlCol="0" anchor="ctr"/>
-          <a:lstStyle/>
-          <a:p>
-            <a:pPr indent="0" marL="0">
-              <a:buNone/>
-            </a:pPr>
-            <a:r>
-              <a:rPr lang="en-US" sz="1500" i="1" dirty="0">
-                <a:solidFill>
-                  <a:srgbClr val="64748B"/>
-                </a:solidFill>
-                <a:latin typeface="Calibri" pitchFamily="34" charset="0"/>
-                <a:ea typeface="Calibri" pitchFamily="34" charset="-122"/>
-                <a:cs typeface="Calibri" pitchFamily="34" charset="-120"/>
-              </a:rPr>
-              <a:t>Your turn. Find the punctuation mark that ends the spoken words. Tap a word to check — green means you got it.</a:t>
-            </a:r>
-            <a:endParaRPr lang="en-US" sz="1500" dirty="0"/>
+              <a:t>The circle of gold and jewels a king or queen wears.</a:t>
+            </a:r>
+            <a:endParaRPr lang="en-US" sz="1700" dirty="0"/>
           </a:p>
         </p:txBody>
       </p:sp>
@@ -3349,7 +3490,7 @@
                 <a:ea typeface="Calibri" pitchFamily="34" charset="-122"/>
                 <a:cs typeface="Calibri" pitchFamily="34" charset="-120"/>
               </a:rPr>
-              <a:t>✏️  Grammar</a:t>
+              <a:t>✏️  Grammar — What do you notice?</a:t>
             </a:r>
             <a:endParaRPr lang="en-US" sz="2200" dirty="0"/>
           </a:p>
@@ -3363,7 +3504,7 @@
         </p:nvSpPr>
         <p:spPr>
           <a:xfrm>
-            <a:off x="365760" y="777240"/>
+            <a:off x="365760" y="749808"/>
             <a:ext cx="8229600" cy="237744"/>
           </a:xfrm>
           <a:prstGeom prst="rect">
@@ -3388,7 +3529,7 @@
                 <a:ea typeface="Calibri" pitchFamily="34" charset="-122"/>
                 <a:cs typeface="Calibri" pitchFamily="34" charset="-120"/>
               </a:rPr>
-              <a:t>DIALOGUE: PUTTING IT TO WORK</a:t>
+              <a:t>ADJECTIVES AND COMPARING</a:t>
             </a:r>
             <a:endParaRPr lang="en-US" sz="1100" dirty="0"/>
           </a:p>
@@ -3396,13 +3537,52 @@
       </p:sp>
       <p:sp>
         <p:nvSpPr>
-          <p:cNvPr id="5" name="Shape 3"/>
-          <p:cNvSpPr/>
-          <p:nvPr/>
-        </p:nvSpPr>
-        <p:spPr>
-          <a:xfrm>
-            <a:off x="365760" y="1078992"/>
+          <p:cNvPr id="5" name="Text 3"/>
+          <p:cNvSpPr/>
+          <p:nvPr/>
+        </p:nvSpPr>
+        <p:spPr>
+          <a:xfrm>
+            <a:off x="365760" y="987552"/>
+            <a:ext cx="8412480" cy="411480"/>
+          </a:xfrm>
+          <a:prstGeom prst="rect">
+            <a:avLst/>
+          </a:prstGeom>
+          <a:noFill/>
+          <a:ln/>
+        </p:spPr>
+        <p:txBody>
+          <a:bodyPr wrap="square" lIns="0" tIns="0" rIns="0" bIns="0" rtlCol="0" anchor="ctr"/>
+          <a:lstStyle/>
+          <a:p>
+            <a:pPr indent="0" marL="0">
+              <a:buNone/>
+            </a:pPr>
+            <a:r>
+              <a:rPr lang="en-US" sz="1500" i="1" dirty="0">
+                <a:solidFill>
+                  <a:srgbClr val="64748B"/>
+                </a:solidFill>
+                <a:latin typeface="Calibri" pitchFamily="34" charset="0"/>
+                <a:ea typeface="Calibri" pitchFamily="34" charset="-122"/>
+                <a:cs typeface="Calibri" pitchFamily="34" charset="-120"/>
+              </a:rPr>
+              <a:t>The same adjective, three shapes. Say all three aloud before you read anything else.</a:t>
+            </a:r>
+            <a:endParaRPr lang="en-US" sz="1500" dirty="0"/>
+          </a:p>
+        </p:txBody>
+      </p:sp>
+      <p:sp>
+        <p:nvSpPr>
+          <p:cNvPr id="6" name="Shape 4"/>
+          <p:cNvSpPr/>
+          <p:nvPr/>
+        </p:nvSpPr>
+        <p:spPr>
+          <a:xfrm>
+            <a:off x="365760" y="1463040"/>
             <a:ext cx="8412480" cy="658368"/>
           </a:xfrm>
           <a:prstGeom prst="roundRect">
@@ -3413,7 +3593,12 @@
           <a:solidFill>
             <a:srgbClr val="FEF6E8"/>
           </a:solidFill>
-          <a:ln/>
+          <a:ln w="19050">
+            <a:solidFill>
+              <a:srgbClr val="C7922C"/>
+            </a:solidFill>
+            <a:prstDash val="solid"/>
+          </a:ln>
           <a:effectLst>
             <a:outerShdw sx="100000" sy="100000" kx="0" ky="0" algn="bl" rotWithShape="0" blurRad="101600" dist="38100" dir="2700000">
               <a:srgbClr val="000000">
@@ -3425,30 +3610,58 @@
       </p:sp>
       <p:sp>
         <p:nvSpPr>
-          <p:cNvPr id="6" name="Text 4"/>
-          <p:cNvSpPr/>
-          <p:nvPr/>
-        </p:nvSpPr>
-        <p:spPr>
-          <a:xfrm>
-            <a:off x="594360" y="1225296"/>
-            <a:ext cx="7863840" cy="402336"/>
-          </a:xfrm>
-          <a:prstGeom prst="rect">
-            <a:avLst/>
-          </a:prstGeom>
-          <a:noFill/>
-          <a:ln/>
-        </p:spPr>
-        <p:txBody>
-          <a:bodyPr wrap="square" lIns="0" tIns="0" rIns="0" bIns="0" rtlCol="0" anchor="ctr"/>
-          <a:lstStyle/>
-          <a:p>
-            <a:pPr indent="0" marL="0">
-              <a:buNone/>
-            </a:pPr>
-            <a:r>
-              <a:rPr lang="en-US" sz="1600" dirty="0">
+          <p:cNvPr id="7" name="Text 5"/>
+          <p:cNvSpPr/>
+          <p:nvPr/>
+        </p:nvSpPr>
+        <p:spPr>
+          <a:xfrm>
+            <a:off x="594360" y="1591056"/>
+            <a:ext cx="7955280" cy="402336"/>
+          </a:xfrm>
+          <a:prstGeom prst="rect">
+            <a:avLst/>
+          </a:prstGeom>
+          <a:noFill/>
+          <a:ln/>
+        </p:spPr>
+        <p:txBody>
+          <a:bodyPr wrap="square" lIns="0" tIns="0" rIns="0" bIns="0" rtlCol="0" anchor="ctr"/>
+          <a:lstStyle/>
+          <a:p>
+            <a:pPr indent="0" marL="0">
+              <a:buNone/>
+            </a:pPr>
+            <a:endParaRPr lang="en-US" sz="1700" dirty="0"/>
+          </a:p>
+        </p:txBody>
+      </p:sp>
+      <p:sp>
+        <p:nvSpPr>
+          <p:cNvPr id="8" name="Text 6"/>
+          <p:cNvSpPr/>
+          <p:nvPr/>
+        </p:nvSpPr>
+        <p:spPr>
+          <a:xfrm>
+            <a:off x="594360" y="1591056"/>
+            <a:ext cx="7955280" cy="402336"/>
+          </a:xfrm>
+          <a:prstGeom prst="rect">
+            <a:avLst/>
+          </a:prstGeom>
+          <a:noFill/>
+          <a:ln/>
+        </p:spPr>
+        <p:txBody>
+          <a:bodyPr wrap="square" lIns="0" tIns="0" rIns="0" bIns="0" rtlCol="0" anchor="ctr"/>
+          <a:lstStyle/>
+          <a:p>
+            <a:pPr indent="0" marL="0">
+              <a:buNone/>
+            </a:pPr>
+            <a:r>
+              <a:rPr lang="en-US" sz="1700" dirty="0">
                 <a:solidFill>
                   <a:srgbClr val="1E293B"/>
                 </a:solidFill>
@@ -3456,27 +3669,13 @@
                 <a:ea typeface="Calibri" pitchFamily="34" charset="-122"/>
                 <a:cs typeface="Calibri" pitchFamily="34" charset="-120"/>
               </a:rPr>
-              <a:t>“I will </a:t>
-            </a:r>
-            <a:pPr indent="0" marL="0">
-              <a:buNone/>
-            </a:pPr>
-            <a:r>
-              <a:rPr lang="en-US" sz="1600" b="1" dirty="0">
-                <a:solidFill>
-                  <a:srgbClr val="34B76F"/>
-                </a:solidFill>
-                <a:latin typeface="Calibri" pitchFamily="34" charset="0"/>
-                <a:ea typeface="Calibri" pitchFamily="34" charset="-122"/>
-                <a:cs typeface="Calibri" pitchFamily="34" charset="-120"/>
-              </a:rPr>
-              <a:t>go,”</a:t>
-            </a:r>
-            <a:pPr indent="0" marL="0">
-              <a:buNone/>
-            </a:pPr>
-            <a:r>
-              <a:rPr lang="en-US" sz="1600" dirty="0">
+              <a:t>small</a:t>
+            </a:r>
+            <a:pPr indent="0" marL="0">
+              <a:buNone/>
+            </a:pPr>
+            <a:r>
+              <a:rPr lang="en-US" sz="1700" dirty="0">
                 <a:solidFill>
                   <a:srgbClr val="1E293B"/>
                 </a:solidFill>
@@ -3484,67 +3683,13 @@
                 <a:ea typeface="Calibri" pitchFamily="34" charset="-122"/>
                 <a:cs typeface="Calibri" pitchFamily="34" charset="-120"/>
               </a:rPr>
-              <a:t> said the mouse.</a:t>
-            </a:r>
-            <a:endParaRPr lang="en-US" sz="1600" dirty="0"/>
-          </a:p>
-        </p:txBody>
-      </p:sp>
-      <p:sp>
-        <p:nvSpPr>
-          <p:cNvPr id="7" name="Shape 5"/>
-          <p:cNvSpPr/>
-          <p:nvPr/>
-        </p:nvSpPr>
-        <p:spPr>
-          <a:xfrm>
-            <a:off x="365760" y="1810512"/>
-            <a:ext cx="8412480" cy="658368"/>
-          </a:xfrm>
-          <a:prstGeom prst="roundRect">
-            <a:avLst>
-              <a:gd name="adj" fmla="val 13889"/>
-            </a:avLst>
-          </a:prstGeom>
-          <a:solidFill>
-            <a:srgbClr val="FFFFFF"/>
-          </a:solidFill>
-          <a:ln/>
-          <a:effectLst>
-            <a:outerShdw sx="100000" sy="100000" kx="0" ky="0" algn="bl" rotWithShape="0" blurRad="101600" dist="38100" dir="2700000">
-              <a:srgbClr val="000000">
-                <a:alpha val="12000"/>
-              </a:srgbClr>
-            </a:outerShdw>
-          </a:effectLst>
-        </p:spPr>
-      </p:sp>
-      <p:sp>
-        <p:nvSpPr>
-          <p:cNvPr id="8" name="Text 6"/>
-          <p:cNvSpPr/>
-          <p:nvPr/>
-        </p:nvSpPr>
-        <p:spPr>
-          <a:xfrm>
-            <a:off x="594360" y="1956816"/>
-            <a:ext cx="7863840" cy="402336"/>
-          </a:xfrm>
-          <a:prstGeom prst="rect">
-            <a:avLst/>
-          </a:prstGeom>
-          <a:noFill/>
-          <a:ln/>
-        </p:spPr>
-        <p:txBody>
-          <a:bodyPr wrap="square" lIns="0" tIns="0" rIns="0" bIns="0" rtlCol="0" anchor="ctr"/>
-          <a:lstStyle/>
-          <a:p>
-            <a:pPr indent="0" marL="0">
-              <a:buNone/>
-            </a:pPr>
-            <a:r>
-              <a:rPr lang="en-US" sz="1600" dirty="0">
+              <a:t> </a:t>
+            </a:r>
+            <a:pPr indent="0" marL="0">
+              <a:buNone/>
+            </a:pPr>
+            <a:r>
+              <a:rPr lang="en-US" sz="1700" dirty="0">
                 <a:solidFill>
                   <a:srgbClr val="1E293B"/>
                 </a:solidFill>
@@ -3552,27 +3697,13 @@
                 <a:ea typeface="Calibri" pitchFamily="34" charset="-122"/>
                 <a:cs typeface="Calibri" pitchFamily="34" charset="-120"/>
               </a:rPr>
-              <a:t>The king </a:t>
-            </a:r>
-            <a:pPr indent="0" marL="0">
-              <a:buNone/>
-            </a:pPr>
-            <a:r>
-              <a:rPr lang="en-US" sz="1600" b="1" dirty="0">
-                <a:solidFill>
-                  <a:srgbClr val="34B76F"/>
-                </a:solidFill>
-                <a:latin typeface="Calibri" pitchFamily="34" charset="0"/>
-                <a:ea typeface="Calibri" pitchFamily="34" charset="-122"/>
-                <a:cs typeface="Calibri" pitchFamily="34" charset="-120"/>
-              </a:rPr>
-              <a:t>shouted,</a:t>
-            </a:r>
-            <a:pPr indent="0" marL="0">
-              <a:buNone/>
-            </a:pPr>
-            <a:r>
-              <a:rPr lang="en-US" sz="1600" dirty="0">
+              <a:t>·</a:t>
+            </a:r>
+            <a:pPr indent="0" marL="0">
+              <a:buNone/>
+            </a:pPr>
+            <a:r>
+              <a:rPr lang="en-US" sz="1700" dirty="0">
                 <a:solidFill>
                   <a:srgbClr val="1E293B"/>
                 </a:solidFill>
@@ -3580,40 +3711,120 @@
                 <a:ea typeface="Calibri" pitchFamily="34" charset="-122"/>
                 <a:cs typeface="Calibri" pitchFamily="34" charset="-120"/>
               </a:rPr>
-              <a:t> “Find her!”</a:t>
-            </a:r>
-            <a:endParaRPr lang="en-US" sz="1600" dirty="0"/>
-          </a:p>
-        </p:txBody>
-      </p:sp>
-      <p:sp>
-        <p:nvSpPr>
-          <p:cNvPr id="9" name="Shape 7"/>
-          <p:cNvSpPr/>
-          <p:nvPr/>
-        </p:nvSpPr>
-        <p:spPr>
-          <a:xfrm>
-            <a:off x="365760" y="2542032"/>
-            <a:ext cx="8412480" cy="658368"/>
-          </a:xfrm>
-          <a:prstGeom prst="roundRect">
-            <a:avLst>
-              <a:gd name="adj" fmla="val 13889"/>
-            </a:avLst>
-          </a:prstGeom>
-          <a:solidFill>
-            <a:srgbClr val="FEF6E8"/>
-          </a:solidFill>
-          <a:ln/>
-          <a:effectLst>
-            <a:outerShdw sx="100000" sy="100000" kx="0" ky="0" algn="bl" rotWithShape="0" blurRad="101600" dist="38100" dir="2700000">
-              <a:srgbClr val="000000">
-                <a:alpha val="12000"/>
-              </a:srgbClr>
-            </a:outerShdw>
-          </a:effectLst>
-        </p:spPr>
+              <a:t> </a:t>
+            </a:r>
+            <a:pPr indent="0" marL="0">
+              <a:buNone/>
+            </a:pPr>
+            <a:r>
+              <a:rPr lang="en-US" sz="1700" dirty="0">
+                <a:solidFill>
+                  <a:srgbClr val="1E293B"/>
+                </a:solidFill>
+                <a:latin typeface="Calibri" pitchFamily="34" charset="0"/>
+                <a:ea typeface="Calibri" pitchFamily="34" charset="-122"/>
+                <a:cs typeface="Calibri" pitchFamily="34" charset="-120"/>
+              </a:rPr>
+              <a:t>smaller</a:t>
+            </a:r>
+            <a:pPr indent="0" marL="0">
+              <a:buNone/>
+            </a:pPr>
+            <a:r>
+              <a:rPr lang="en-US" sz="1700" dirty="0">
+                <a:solidFill>
+                  <a:srgbClr val="1E293B"/>
+                </a:solidFill>
+                <a:latin typeface="Calibri" pitchFamily="34" charset="0"/>
+                <a:ea typeface="Calibri" pitchFamily="34" charset="-122"/>
+                <a:cs typeface="Calibri" pitchFamily="34" charset="-120"/>
+              </a:rPr>
+              <a:t> </a:t>
+            </a:r>
+            <a:pPr indent="0" marL="0">
+              <a:buNone/>
+            </a:pPr>
+            <a:r>
+              <a:rPr lang="en-US" sz="1700" dirty="0">
+                <a:solidFill>
+                  <a:srgbClr val="1E293B"/>
+                </a:solidFill>
+                <a:latin typeface="Calibri" pitchFamily="34" charset="0"/>
+                <a:ea typeface="Calibri" pitchFamily="34" charset="-122"/>
+                <a:cs typeface="Calibri" pitchFamily="34" charset="-120"/>
+              </a:rPr>
+              <a:t>·</a:t>
+            </a:r>
+            <a:pPr indent="0" marL="0">
+              <a:buNone/>
+            </a:pPr>
+            <a:r>
+              <a:rPr lang="en-US" sz="1700" dirty="0">
+                <a:solidFill>
+                  <a:srgbClr val="1E293B"/>
+                </a:solidFill>
+                <a:latin typeface="Calibri" pitchFamily="34" charset="0"/>
+                <a:ea typeface="Calibri" pitchFamily="34" charset="-122"/>
+                <a:cs typeface="Calibri" pitchFamily="34" charset="-120"/>
+              </a:rPr>
+              <a:t> </a:t>
+            </a:r>
+            <a:pPr indent="0" marL="0">
+              <a:buNone/>
+            </a:pPr>
+            <a:r>
+              <a:rPr lang="en-US" sz="1700" dirty="0">
+                <a:solidFill>
+                  <a:srgbClr val="1E293B"/>
+                </a:solidFill>
+                <a:latin typeface="Calibri" pitchFamily="34" charset="0"/>
+                <a:ea typeface="Calibri" pitchFamily="34" charset="-122"/>
+                <a:cs typeface="Calibri" pitchFamily="34" charset="-120"/>
+              </a:rPr>
+              <a:t>smallest</a:t>
+            </a:r>
+            <a:endParaRPr lang="en-US" sz="1700" dirty="0"/>
+          </a:p>
+        </p:txBody>
+      </p:sp>
+      <p:sp>
+        <p:nvSpPr>
+          <p:cNvPr id="9" name="Text 7"/>
+          <p:cNvSpPr/>
+          <p:nvPr/>
+        </p:nvSpPr>
+        <p:spPr>
+          <a:xfrm>
+            <a:off x="365760" y="2258568"/>
+            <a:ext cx="8229600" cy="237744"/>
+          </a:xfrm>
+          <a:prstGeom prst="rect">
+            <a:avLst/>
+          </a:prstGeom>
+          <a:noFill/>
+          <a:ln/>
+        </p:spPr>
+        <p:txBody>
+          <a:bodyPr wrap="square" lIns="0" tIns="0" rIns="0" bIns="0" rtlCol="0" anchor="ctr"/>
+          <a:lstStyle/>
+          <a:p>
+            <a:pPr indent="0" marL="0">
+              <a:buNone/>
+            </a:pPr>
+            <a:r>
+              <a:rPr lang="en-US" sz="1100" b="1" spc="100" kern="0" dirty="0">
+                <a:solidFill>
+                  <a:srgbClr val="C7922C"/>
+                </a:solidFill>
+                <a:latin typeface="Calibri" pitchFamily="34" charset="0"/>
+                <a:ea typeface="Calibri" pitchFamily="34" charset="-122"/>
+                <a:cs typeface="Calibri" pitchFamily="34" charset="-120"/>
+              </a:rPr>
+              <a:t>THINK IT THROUGH</a:t>
+            </a:r>
+            <a:endParaRPr lang="en-US" sz="1100" dirty="0"/>
+          </a:p>
+        </p:txBody>
       </p:sp>
       <p:sp>
         <p:nvSpPr>
@@ -3623,38 +3834,24 @@
         </p:nvSpPr>
         <p:spPr>
           <a:xfrm>
-            <a:off x="594360" y="2688336"/>
-            <a:ext cx="7863840" cy="402336"/>
-          </a:xfrm>
-          <a:prstGeom prst="rect">
-            <a:avLst/>
-          </a:prstGeom>
-          <a:noFill/>
-          <a:ln/>
-        </p:spPr>
-        <p:txBody>
-          <a:bodyPr wrap="square" lIns="0" tIns="0" rIns="0" bIns="0" rtlCol="0" anchor="ctr"/>
-          <a:lstStyle/>
-          <a:p>
-            <a:pPr indent="0" marL="0">
-              <a:buNone/>
-            </a:pPr>
-            <a:r>
-              <a:rPr lang="en-US" sz="1600" b="1" dirty="0">
-                <a:solidFill>
-                  <a:srgbClr val="34B76F"/>
-                </a:solidFill>
-                <a:latin typeface="Calibri" pitchFamily="34" charset="0"/>
-                <a:ea typeface="Calibri" pitchFamily="34" charset="-122"/>
-                <a:cs typeface="Calibri" pitchFamily="34" charset="-120"/>
-              </a:rPr>
-              <a:t>“Gone,”</a:t>
-            </a:r>
-            <a:pPr indent="0" marL="0">
-              <a:buNone/>
-            </a:pPr>
-            <a:r>
-              <a:rPr lang="en-US" sz="1600" dirty="0">
+            <a:off x="365760" y="2505456"/>
+            <a:ext cx="8412480" cy="2313432"/>
+          </a:xfrm>
+          <a:prstGeom prst="rect">
+            <a:avLst/>
+          </a:prstGeom>
+          <a:noFill/>
+          <a:ln/>
+        </p:spPr>
+        <p:txBody>
+          <a:bodyPr wrap="square" lIns="0" tIns="0" rIns="0" bIns="0" rtlCol="0" anchor="t"/>
+          <a:lstStyle/>
+          <a:p>
+            <a:pPr indent="0" marL="0">
+              <a:buNone/>
+            </a:pPr>
+            <a:r>
+              <a:rPr lang="en-US" sz="1400" dirty="0">
                 <a:solidFill>
                   <a:srgbClr val="1E293B"/>
                 </a:solidFill>
@@ -3662,67 +3859,16 @@
                 <a:ea typeface="Calibri" pitchFamily="34" charset="-122"/>
                 <a:cs typeface="Calibri" pitchFamily="34" charset="-120"/>
               </a:rPr>
-              <a:t> said Cook quietly.</a:t>
-            </a:r>
-            <a:endParaRPr lang="en-US" sz="1600" dirty="0"/>
-          </a:p>
-        </p:txBody>
-      </p:sp>
-      <p:sp>
-        <p:nvSpPr>
-          <p:cNvPr id="11" name="Shape 9"/>
-          <p:cNvSpPr/>
-          <p:nvPr/>
-        </p:nvSpPr>
-        <p:spPr>
-          <a:xfrm>
-            <a:off x="365760" y="3273552"/>
-            <a:ext cx="8412480" cy="658368"/>
-          </a:xfrm>
-          <a:prstGeom prst="roundRect">
-            <a:avLst>
-              <a:gd name="adj" fmla="val 13889"/>
-            </a:avLst>
-          </a:prstGeom>
-          <a:solidFill>
-            <a:srgbClr val="FFFFFF"/>
-          </a:solidFill>
-          <a:ln/>
-          <a:effectLst>
-            <a:outerShdw sx="100000" sy="100000" kx="0" ky="0" algn="bl" rotWithShape="0" blurRad="101600" dist="38100" dir="2700000">
-              <a:srgbClr val="000000">
-                <a:alpha val="12000"/>
-              </a:srgbClr>
-            </a:outerShdw>
-          </a:effectLst>
-        </p:spPr>
-      </p:sp>
-      <p:sp>
-        <p:nvSpPr>
-          <p:cNvPr id="12" name="Text 10"/>
-          <p:cNvSpPr/>
-          <p:nvPr/>
-        </p:nvSpPr>
-        <p:spPr>
-          <a:xfrm>
-            <a:off x="594360" y="3419856"/>
-            <a:ext cx="7863840" cy="402336"/>
-          </a:xfrm>
-          <a:prstGeom prst="rect">
-            <a:avLst/>
-          </a:prstGeom>
-          <a:noFill/>
-          <a:ln/>
-        </p:spPr>
-        <p:txBody>
-          <a:bodyPr wrap="square" lIns="0" tIns="0" rIns="0" bIns="0" rtlCol="0" anchor="ctr"/>
-          <a:lstStyle/>
-          <a:p>
-            <a:pPr indent="0" marL="0">
-              <a:buNone/>
-            </a:pPr>
-            <a:r>
-              <a:rPr lang="en-US" sz="1600" dirty="0">
+              <a:t>1.  What did you add to small to make each new word?</a:t>
+            </a:r>
+            <a:endParaRPr lang="en-US" sz="1400" dirty="0"/>
+          </a:p>
+          <a:p>
+            <a:pPr indent="0" marL="0">
+              <a:buNone/>
+            </a:pPr>
+            <a:r>
+              <a:rPr lang="en-US" sz="1400" dirty="0">
                 <a:solidFill>
                   <a:srgbClr val="1E293B"/>
                 </a:solidFill>
@@ -3730,27 +3876,16 @@
                 <a:ea typeface="Calibri" pitchFamily="34" charset="-122"/>
                 <a:cs typeface="Calibri" pitchFamily="34" charset="-120"/>
               </a:rPr>
-              <a:t>“Where is </a:t>
-            </a:r>
-            <a:pPr indent="0" marL="0">
-              <a:buNone/>
-            </a:pPr>
-            <a:r>
-              <a:rPr lang="en-US" sz="1600" b="1" dirty="0">
-                <a:solidFill>
-                  <a:srgbClr val="34B76F"/>
-                </a:solidFill>
-                <a:latin typeface="Calibri" pitchFamily="34" charset="0"/>
-                <a:ea typeface="Calibri" pitchFamily="34" charset="-122"/>
-                <a:cs typeface="Calibri" pitchFamily="34" charset="-120"/>
-              </a:rPr>
-              <a:t>she?”</a:t>
-            </a:r>
-            <a:pPr indent="0" marL="0">
-              <a:buNone/>
-            </a:pPr>
-            <a:r>
-              <a:rPr lang="en-US" sz="1600" dirty="0">
+              <a:t>2.  One shape compares two things. One compares three or more. Which is which?</a:t>
+            </a:r>
+            <a:endParaRPr lang="en-US" sz="1400" dirty="0"/>
+          </a:p>
+          <a:p>
+            <a:pPr indent="0" marL="0">
+              <a:buNone/>
+            </a:pPr>
+            <a:r>
+              <a:rPr lang="en-US" sz="1400" dirty="0">
                 <a:solidFill>
                   <a:srgbClr val="1E293B"/>
                 </a:solidFill>
@@ -3758,48 +3893,9 @@
                 <a:ea typeface="Calibri" pitchFamily="34" charset="-122"/>
                 <a:cs typeface="Calibri" pitchFamily="34" charset="-120"/>
               </a:rPr>
-              <a:t> asked Despereaux.</a:t>
-            </a:r>
-            <a:endParaRPr lang="en-US" sz="1600" dirty="0"/>
-          </a:p>
-        </p:txBody>
-      </p:sp>
-      <p:sp>
-        <p:nvSpPr>
-          <p:cNvPr id="13" name="Text 11"/>
-          <p:cNvSpPr/>
-          <p:nvPr/>
-        </p:nvSpPr>
-        <p:spPr>
-          <a:xfrm>
-            <a:off x="365760" y="4050792"/>
-            <a:ext cx="8412480" cy="365760"/>
-          </a:xfrm>
-          <a:prstGeom prst="rect">
-            <a:avLst/>
-          </a:prstGeom>
-          <a:noFill/>
-          <a:ln/>
-        </p:spPr>
-        <p:txBody>
-          <a:bodyPr wrap="square" lIns="0" tIns="0" rIns="0" bIns="0" rtlCol="0" anchor="ctr"/>
-          <a:lstStyle/>
-          <a:p>
-            <a:pPr indent="0" marL="0">
-              <a:buNone/>
-            </a:pPr>
-            <a:r>
-              <a:rPr lang="en-US" sz="1500" b="1" dirty="0">
-                <a:solidFill>
-                  <a:srgbClr val="34B76F"/>
-                </a:solidFill>
-                <a:latin typeface="Calibri" pitchFamily="34" charset="0"/>
-                <a:ea typeface="Calibri" pitchFamily="34" charset="-122"/>
-                <a:cs typeface="Calibri" pitchFamily="34" charset="-120"/>
-              </a:rPr>
-              <a:t>✅  Answers revealed</a:t>
-            </a:r>
-            <a:endParaRPr lang="en-US" sz="1500" dirty="0"/>
+              <a:t>3.  Try it with dark. Say all three shapes.</a:t>
+            </a:r>
+            <a:endParaRPr lang="en-US" sz="1400" dirty="0"/>
           </a:p>
         </p:txBody>
       </p:sp>
@@ -3850,7 +3946,7 @@
             <a:avLst/>
           </a:prstGeom>
           <a:solidFill>
-            <a:srgbClr val="0E1C42"/>
+            <a:srgbClr val="C7922C"/>
           </a:solidFill>
           <a:ln/>
         </p:spPr>
@@ -3888,7 +3984,7 @@
                 <a:ea typeface="Calibri" pitchFamily="34" charset="-122"/>
                 <a:cs typeface="Calibri" pitchFamily="34" charset="-120"/>
               </a:rPr>
-              <a:t>🔠  Spelling</a:t>
+              <a:t>✏️  Grammar — What do you notice?</a:t>
             </a:r>
             <a:endParaRPr lang="en-US" sz="2200" dirty="0"/>
           </a:p>
@@ -3902,7 +3998,7 @@
         </p:nvSpPr>
         <p:spPr>
           <a:xfrm>
-            <a:off x="365760" y="777240"/>
+            <a:off x="365760" y="749808"/>
             <a:ext cx="8229600" cy="237744"/>
           </a:xfrm>
           <a:prstGeom prst="rect">
@@ -3921,13 +4017,13 @@
             <a:r>
               <a:rPr lang="en-US" sz="1100" b="1" spc="100" kern="0" dirty="0">
                 <a:solidFill>
-                  <a:srgbClr val="0E1C42"/>
-                </a:solidFill>
-                <a:latin typeface="Calibri" pitchFamily="34" charset="0"/>
-                <a:ea typeface="Calibri" pitchFamily="34" charset="-122"/>
-                <a:cs typeface="Calibri" pitchFamily="34" charset="-120"/>
-              </a:rPr>
-              <a:t>SOFT C AND SOFT G</a:t>
+                  <a:srgbClr val="C7922C"/>
+                </a:solidFill>
+                <a:latin typeface="Calibri" pitchFamily="34" charset="0"/>
+                <a:ea typeface="Calibri" pitchFamily="34" charset="-122"/>
+                <a:cs typeface="Calibri" pitchFamily="34" charset="-120"/>
+              </a:rPr>
+              <a:t>ADJECTIVES AND COMPARING</a:t>
             </a:r>
             <a:endParaRPr lang="en-US" sz="1100" dirty="0"/>
           </a:p>
@@ -3941,24 +4037,24 @@
         </p:nvSpPr>
         <p:spPr>
           <a:xfrm>
-            <a:off x="365760" y="1078992"/>
-            <a:ext cx="8229600" cy="237744"/>
-          </a:xfrm>
-          <a:prstGeom prst="rect">
-            <a:avLst/>
-          </a:prstGeom>
-          <a:noFill/>
-          <a:ln/>
-        </p:spPr>
-        <p:txBody>
-          <a:bodyPr wrap="square" lIns="0" tIns="0" rIns="0" bIns="0" rtlCol="0" anchor="ctr"/>
-          <a:lstStyle/>
-          <a:p>
-            <a:pPr indent="0" marL="0">
-              <a:buNone/>
-            </a:pPr>
-            <a:r>
-              <a:rPr lang="en-US" sz="1100" b="1" spc="100" kern="0" dirty="0">
+            <a:off x="365760" y="987552"/>
+            <a:ext cx="8412480" cy="411480"/>
+          </a:xfrm>
+          <a:prstGeom prst="rect">
+            <a:avLst/>
+          </a:prstGeom>
+          <a:noFill/>
+          <a:ln/>
+        </p:spPr>
+        <p:txBody>
+          <a:bodyPr wrap="square" lIns="0" tIns="0" rIns="0" bIns="0" rtlCol="0" anchor="ctr"/>
+          <a:lstStyle/>
+          <a:p>
+            <a:pPr indent="0" marL="0">
+              <a:buNone/>
+            </a:pPr>
+            <a:r>
+              <a:rPr lang="en-US" sz="1500" i="1" dirty="0">
                 <a:solidFill>
                   <a:srgbClr val="64748B"/>
                 </a:solidFill>
@@ -3966,9 +4062,9 @@
                 <a:ea typeface="Calibri" pitchFamily="34" charset="-122"/>
                 <a:cs typeface="Calibri" pitchFamily="34" charset="-120"/>
               </a:rPr>
-              <a:t>WORD BANK</a:t>
-            </a:r>
-            <a:endParaRPr lang="en-US" sz="1100" dirty="0"/>
+              <a:t>The same adjective, three shapes. Say all three aloud before you read anything else.</a:t>
+            </a:r>
+            <a:endParaRPr lang="en-US" sz="1500" dirty="0"/>
           </a:p>
         </p:txBody>
       </p:sp>
@@ -3980,20 +4076,20 @@
         </p:nvSpPr>
         <p:spPr>
           <a:xfrm>
-            <a:off x="365760" y="1353312"/>
-            <a:ext cx="8412480" cy="1005840"/>
+            <a:off x="365760" y="1463040"/>
+            <a:ext cx="8412480" cy="658368"/>
           </a:xfrm>
           <a:prstGeom prst="roundRect">
             <a:avLst>
-              <a:gd name="adj" fmla="val 9091"/>
+              <a:gd name="adj" fmla="val 13889"/>
             </a:avLst>
           </a:prstGeom>
           <a:solidFill>
-            <a:srgbClr val="FFFFFF"/>
+            <a:srgbClr val="FEF6E8"/>
           </a:solidFill>
           <a:ln w="19050">
             <a:solidFill>
-              <a:srgbClr val="0E1C42"/>
+              <a:srgbClr val="C7922C"/>
             </a:solidFill>
             <a:prstDash val="solid"/>
           </a:ln>
@@ -4014,8 +4110,36 @@
         </p:nvSpPr>
         <p:spPr>
           <a:xfrm>
-            <a:off x="594360" y="1481328"/>
-            <a:ext cx="7955280" cy="749808"/>
+            <a:off x="594360" y="1591056"/>
+            <a:ext cx="7955280" cy="402336"/>
+          </a:xfrm>
+          <a:prstGeom prst="rect">
+            <a:avLst/>
+          </a:prstGeom>
+          <a:noFill/>
+          <a:ln/>
+        </p:spPr>
+        <p:txBody>
+          <a:bodyPr wrap="square" lIns="0" tIns="0" rIns="0" bIns="0" rtlCol="0" anchor="ctr"/>
+          <a:lstStyle/>
+          <a:p>
+            <a:pPr indent="0" marL="0">
+              <a:buNone/>
+            </a:pPr>
+            <a:endParaRPr lang="en-US" sz="1700" dirty="0"/>
+          </a:p>
+        </p:txBody>
+      </p:sp>
+      <p:sp>
+        <p:nvSpPr>
+          <p:cNvPr id="8" name="Text 6"/>
+          <p:cNvSpPr/>
+          <p:nvPr/>
+        </p:nvSpPr>
+        <p:spPr>
+          <a:xfrm>
+            <a:off x="594360" y="1591056"/>
+            <a:ext cx="7955280" cy="402336"/>
           </a:xfrm>
           <a:prstGeom prst="rect">
             <a:avLst/>
@@ -4033,13 +4157,125 @@
             <a:r>
               <a:rPr lang="en-US" sz="1700" dirty="0">
                 <a:solidFill>
-                  <a:srgbClr val="0E1C42"/>
-                </a:solidFill>
-                <a:latin typeface="Calibri" pitchFamily="34" charset="0"/>
-                <a:ea typeface="Calibri" pitchFamily="34" charset="-122"/>
-                <a:cs typeface="Calibri" pitchFamily="34" charset="-120"/>
-              </a:rPr>
-              <a:t>garlic   ·   gold   ·   candle   ·   Cook   ·   gentle   ·   magic   ·   prince   ·   mice</a:t>
+                  <a:srgbClr val="1E293B"/>
+                </a:solidFill>
+                <a:latin typeface="Calibri" pitchFamily="34" charset="0"/>
+                <a:ea typeface="Calibri" pitchFamily="34" charset="-122"/>
+                <a:cs typeface="Calibri" pitchFamily="34" charset="-120"/>
+              </a:rPr>
+              <a:t>small</a:t>
+            </a:r>
+            <a:pPr indent="0" marL="0">
+              <a:buNone/>
+            </a:pPr>
+            <a:r>
+              <a:rPr lang="en-US" sz="1700" dirty="0">
+                <a:solidFill>
+                  <a:srgbClr val="1E293B"/>
+                </a:solidFill>
+                <a:latin typeface="Calibri" pitchFamily="34" charset="0"/>
+                <a:ea typeface="Calibri" pitchFamily="34" charset="-122"/>
+                <a:cs typeface="Calibri" pitchFamily="34" charset="-120"/>
+              </a:rPr>
+              <a:t> </a:t>
+            </a:r>
+            <a:pPr indent="0" marL="0">
+              <a:buNone/>
+            </a:pPr>
+            <a:r>
+              <a:rPr lang="en-US" sz="1700" dirty="0">
+                <a:solidFill>
+                  <a:srgbClr val="1E293B"/>
+                </a:solidFill>
+                <a:latin typeface="Calibri" pitchFamily="34" charset="0"/>
+                <a:ea typeface="Calibri" pitchFamily="34" charset="-122"/>
+                <a:cs typeface="Calibri" pitchFamily="34" charset="-120"/>
+              </a:rPr>
+              <a:t>·</a:t>
+            </a:r>
+            <a:pPr indent="0" marL="0">
+              <a:buNone/>
+            </a:pPr>
+            <a:r>
+              <a:rPr lang="en-US" sz="1700" dirty="0">
+                <a:solidFill>
+                  <a:srgbClr val="1E293B"/>
+                </a:solidFill>
+                <a:latin typeface="Calibri" pitchFamily="34" charset="0"/>
+                <a:ea typeface="Calibri" pitchFamily="34" charset="-122"/>
+                <a:cs typeface="Calibri" pitchFamily="34" charset="-120"/>
+              </a:rPr>
+              <a:t> </a:t>
+            </a:r>
+            <a:pPr indent="0" marL="0">
+              <a:buNone/>
+            </a:pPr>
+            <a:r>
+              <a:rPr lang="en-US" sz="1700" dirty="0">
+                <a:solidFill>
+                  <a:srgbClr val="1E293B"/>
+                </a:solidFill>
+                <a:latin typeface="Calibri" pitchFamily="34" charset="0"/>
+                <a:ea typeface="Calibri" pitchFamily="34" charset="-122"/>
+                <a:cs typeface="Calibri" pitchFamily="34" charset="-120"/>
+              </a:rPr>
+              <a:t>smaller</a:t>
+            </a:r>
+            <a:pPr indent="0" marL="0">
+              <a:buNone/>
+            </a:pPr>
+            <a:r>
+              <a:rPr lang="en-US" sz="1700" dirty="0">
+                <a:solidFill>
+                  <a:srgbClr val="1E293B"/>
+                </a:solidFill>
+                <a:latin typeface="Calibri" pitchFamily="34" charset="0"/>
+                <a:ea typeface="Calibri" pitchFamily="34" charset="-122"/>
+                <a:cs typeface="Calibri" pitchFamily="34" charset="-120"/>
+              </a:rPr>
+              <a:t> </a:t>
+            </a:r>
+            <a:pPr indent="0" marL="0">
+              <a:buNone/>
+            </a:pPr>
+            <a:r>
+              <a:rPr lang="en-US" sz="1700" dirty="0">
+                <a:solidFill>
+                  <a:srgbClr val="1E293B"/>
+                </a:solidFill>
+                <a:latin typeface="Calibri" pitchFamily="34" charset="0"/>
+                <a:ea typeface="Calibri" pitchFamily="34" charset="-122"/>
+                <a:cs typeface="Calibri" pitchFamily="34" charset="-120"/>
+              </a:rPr>
+              <a:t>·</a:t>
+            </a:r>
+            <a:pPr indent="0" marL="0">
+              <a:buNone/>
+            </a:pPr>
+            <a:r>
+              <a:rPr lang="en-US" sz="1700" dirty="0">
+                <a:solidFill>
+                  <a:srgbClr val="1E293B"/>
+                </a:solidFill>
+                <a:latin typeface="Calibri" pitchFamily="34" charset="0"/>
+                <a:ea typeface="Calibri" pitchFamily="34" charset="-122"/>
+                <a:cs typeface="Calibri" pitchFamily="34" charset="-120"/>
+              </a:rPr>
+              <a:t> </a:t>
+            </a:r>
+            <a:pPr indent="0" marL="0">
+              <a:buNone/>
+            </a:pPr>
+            <a:r>
+              <a:rPr lang="en-US" sz="1700" dirty="0">
+                <a:solidFill>
+                  <a:srgbClr val="1E293B"/>
+                </a:solidFill>
+                <a:latin typeface="Calibri" pitchFamily="34" charset="0"/>
+                <a:ea typeface="Calibri" pitchFamily="34" charset="-122"/>
+                <a:cs typeface="Calibri" pitchFamily="34" charset="-120"/>
+              </a:rPr>
+              <a:t>smallest</a:t>
             </a:r>
             <a:endParaRPr lang="en-US" sz="1700" dirty="0"/>
           </a:p>
@@ -4047,40 +4283,110 @@
       </p:sp>
       <p:sp>
         <p:nvSpPr>
-          <p:cNvPr id="8" name="Text 6"/>
-          <p:cNvSpPr/>
-          <p:nvPr/>
-        </p:nvSpPr>
-        <p:spPr>
-          <a:xfrm>
-            <a:off x="365760" y="2514600"/>
-            <a:ext cx="8412480" cy="457200"/>
-          </a:xfrm>
-          <a:prstGeom prst="rect">
-            <a:avLst/>
-          </a:prstGeom>
-          <a:noFill/>
-          <a:ln/>
-        </p:spPr>
-        <p:txBody>
-          <a:bodyPr wrap="square" lIns="0" tIns="0" rIns="0" bIns="0" rtlCol="0" anchor="ctr"/>
-          <a:lstStyle/>
-          <a:p>
-            <a:pPr indent="0" marL="0">
-              <a:buNone/>
-            </a:pPr>
-            <a:r>
-              <a:rPr lang="en-US" sz="1500" i="1" dirty="0">
-                <a:solidFill>
-                  <a:srgbClr val="64748B"/>
-                </a:solidFill>
-                <a:latin typeface="Calibri" pitchFamily="34" charset="0"/>
-                <a:ea typeface="Calibri" pitchFamily="34" charset="-122"/>
-                <a:cs typeface="Calibri" pitchFamily="34" charset="-120"/>
-              </a:rPr>
-              <a:t>Which column does each word belong in?  Columns: Hard (/k/ or /g/)  |  Soft (/s/ or /j/)</a:t>
-            </a:r>
-            <a:endParaRPr lang="en-US" sz="1500" dirty="0"/>
+          <p:cNvPr id="9" name="Shape 7"/>
+          <p:cNvSpPr/>
+          <p:nvPr/>
+        </p:nvSpPr>
+        <p:spPr>
+          <a:xfrm>
+            <a:off x="365760" y="2258568"/>
+            <a:ext cx="8412480" cy="2587752"/>
+          </a:xfrm>
+          <a:prstGeom prst="roundRect">
+            <a:avLst>
+              <a:gd name="adj" fmla="val 3534"/>
+            </a:avLst>
+          </a:prstGeom>
+          <a:solidFill>
+            <a:srgbClr val="E8F8EF"/>
+          </a:solidFill>
+          <a:ln/>
+          <a:effectLst>
+            <a:outerShdw sx="100000" sy="100000" kx="0" ky="0" algn="bl" rotWithShape="0" blurRad="101600" dist="38100" dir="2700000">
+              <a:srgbClr val="000000">
+                <a:alpha val="12000"/>
+              </a:srgbClr>
+            </a:outerShdw>
+          </a:effectLst>
+        </p:spPr>
+      </p:sp>
+      <p:sp>
+        <p:nvSpPr>
+          <p:cNvPr id="10" name="Text 8"/>
+          <p:cNvSpPr/>
+          <p:nvPr/>
+        </p:nvSpPr>
+        <p:spPr>
+          <a:xfrm>
+            <a:off x="566928" y="2322576"/>
+            <a:ext cx="8229600" cy="237744"/>
+          </a:xfrm>
+          <a:prstGeom prst="rect">
+            <a:avLst/>
+          </a:prstGeom>
+          <a:noFill/>
+          <a:ln/>
+        </p:spPr>
+        <p:txBody>
+          <a:bodyPr wrap="square" lIns="0" tIns="0" rIns="0" bIns="0" rtlCol="0" anchor="ctr"/>
+          <a:lstStyle/>
+          <a:p>
+            <a:pPr indent="0" marL="0">
+              <a:buNone/>
+            </a:pPr>
+            <a:r>
+              <a:rPr lang="en-US" sz="1100" b="1" spc="100" kern="0" dirty="0">
+                <a:solidFill>
+                  <a:srgbClr val="34B76F"/>
+                </a:solidFill>
+                <a:latin typeface="Calibri" pitchFamily="34" charset="0"/>
+                <a:ea typeface="Calibri" pitchFamily="34" charset="-122"/>
+                <a:cs typeface="Calibri" pitchFamily="34" charset="-120"/>
+              </a:rPr>
+              <a:t>✅  THE PATTERN</a:t>
+            </a:r>
+            <a:endParaRPr lang="en-US" sz="1100" dirty="0"/>
+          </a:p>
+        </p:txBody>
+      </p:sp>
+      <p:sp>
+        <p:nvSpPr>
+          <p:cNvPr id="11" name="Text 9"/>
+          <p:cNvSpPr/>
+          <p:nvPr/>
+        </p:nvSpPr>
+        <p:spPr>
+          <a:xfrm>
+            <a:off x="566928" y="2578608"/>
+            <a:ext cx="8010144" cy="2130552"/>
+          </a:xfrm>
+          <a:prstGeom prst="rect">
+            <a:avLst/>
+          </a:prstGeom>
+          <a:noFill/>
+          <a:ln/>
+        </p:spPr>
+        <p:txBody>
+          <a:bodyPr wrap="square" lIns="0" tIns="0" rIns="0" bIns="0" rtlCol="0" anchor="t">
+            <a:normAutofit/>
+          </a:bodyPr>
+          <a:lstStyle/>
+          <a:p>
+            <a:pPr indent="0" marL="0">
+              <a:buNone/>
+            </a:pPr>
+            <a:r>
+              <a:rPr lang="en-US" sz="1300" dirty="0">
+                <a:solidFill>
+                  <a:srgbClr val="1E293B"/>
+                </a:solidFill>
+                <a:latin typeface="Calibri" pitchFamily="34" charset="0"/>
+                <a:ea typeface="Calibri" pitchFamily="34" charset="-122"/>
+                <a:cs typeface="Calibri" pitchFamily="34" charset="-120"/>
+              </a:rPr>
+              <a:t>Add -er to compare two things. Add -est to compare three or more. So: small, smaller, smallest.</a:t>
+            </a:r>
+            <a:endParaRPr lang="en-US" sz="1300" dirty="0"/>
           </a:p>
         </p:txBody>
       </p:sp>
@@ -4131,7 +4437,7 @@
             <a:avLst/>
           </a:prstGeom>
           <a:solidFill>
-            <a:srgbClr val="0E1C42"/>
+            <a:srgbClr val="C7922C"/>
           </a:solidFill>
           <a:ln/>
         </p:spPr>
@@ -4169,7 +4475,7 @@
                 <a:ea typeface="Calibri" pitchFamily="34" charset="-122"/>
                 <a:cs typeface="Calibri" pitchFamily="34" charset="-120"/>
               </a:rPr>
-              <a:t>🔠  Spelling</a:t>
+              <a:t>✏️  Grammar</a:t>
             </a:r>
             <a:endParaRPr lang="en-US" sz="2200" dirty="0"/>
           </a:p>
@@ -4202,13 +4508,13 @@
             <a:r>
               <a:rPr lang="en-US" sz="1100" b="1" spc="100" kern="0" dirty="0">
                 <a:solidFill>
-                  <a:srgbClr val="0E1C42"/>
-                </a:solidFill>
-                <a:latin typeface="Calibri" pitchFamily="34" charset="0"/>
-                <a:ea typeface="Calibri" pitchFamily="34" charset="-122"/>
-                <a:cs typeface="Calibri" pitchFamily="34" charset="-120"/>
-              </a:rPr>
-              <a:t>SOFT C AND SOFT G</a:t>
+                  <a:srgbClr val="C7922C"/>
+                </a:solidFill>
+                <a:latin typeface="Calibri" pitchFamily="34" charset="0"/>
+                <a:ea typeface="Calibri" pitchFamily="34" charset="-122"/>
+                <a:cs typeface="Calibri" pitchFamily="34" charset="-120"/>
+              </a:rPr>
+              <a:t>ADJECTIVES AND COMPARING</a:t>
             </a:r>
             <a:endParaRPr lang="en-US" sz="1100" dirty="0"/>
           </a:p>
@@ -4222,77 +4528,16 @@
         </p:nvSpPr>
         <p:spPr>
           <a:xfrm>
-            <a:off x="411480" y="1078992"/>
-            <a:ext cx="4114800" cy="457200"/>
+            <a:off x="365760" y="1078992"/>
+            <a:ext cx="8412480" cy="658368"/>
           </a:xfrm>
           <a:prstGeom prst="roundRect">
             <a:avLst>
-              <a:gd name="adj" fmla="val 16000"/>
+              <a:gd name="adj" fmla="val 13889"/>
             </a:avLst>
           </a:prstGeom>
           <a:solidFill>
-            <a:srgbClr val="0E1C42"/>
-          </a:solidFill>
-          <a:ln/>
-        </p:spPr>
-      </p:sp>
-      <p:sp>
-        <p:nvSpPr>
-          <p:cNvPr id="6" name="Text 4"/>
-          <p:cNvSpPr/>
-          <p:nvPr/>
-        </p:nvSpPr>
-        <p:spPr>
-          <a:xfrm>
-            <a:off x="457200" y="1133856"/>
-            <a:ext cx="4023360" cy="347472"/>
-          </a:xfrm>
-          <a:prstGeom prst="rect">
-            <a:avLst/>
-          </a:prstGeom>
-          <a:noFill/>
-          <a:ln/>
-        </p:spPr>
-        <p:txBody>
-          <a:bodyPr wrap="square" lIns="0" tIns="0" rIns="0" bIns="0" rtlCol="0" anchor="ctr"/>
-          <a:lstStyle/>
-          <a:p>
-            <a:pPr algn="ctr" indent="0" marL="0">
-              <a:buNone/>
-            </a:pPr>
-            <a:r>
-              <a:rPr lang="en-US" sz="1300" b="1" dirty="0">
-                <a:solidFill>
-                  <a:srgbClr val="FFFFFF"/>
-                </a:solidFill>
-                <a:latin typeface="Calibri" pitchFamily="34" charset="0"/>
-                <a:ea typeface="Calibri" pitchFamily="34" charset="-122"/>
-                <a:cs typeface="Calibri" pitchFamily="34" charset="-120"/>
-              </a:rPr>
-              <a:t>Hard (/k/ or /g/)</a:t>
-            </a:r>
-            <a:endParaRPr lang="en-US" sz="1300" dirty="0"/>
-          </a:p>
-        </p:txBody>
-      </p:sp>
-      <p:sp>
-        <p:nvSpPr>
-          <p:cNvPr id="7" name="Shape 5"/>
-          <p:cNvSpPr/>
-          <p:nvPr/>
-        </p:nvSpPr>
-        <p:spPr>
-          <a:xfrm>
-            <a:off x="411480" y="1591056"/>
-            <a:ext cx="4114800" cy="2103120"/>
-          </a:xfrm>
-          <a:prstGeom prst="roundRect">
-            <a:avLst>
-              <a:gd name="adj" fmla="val 4348"/>
-            </a:avLst>
-          </a:prstGeom>
-          <a:solidFill>
-            <a:srgbClr val="FFFFFF"/>
+            <a:srgbClr val="FEF6E8"/>
           </a:solidFill>
           <a:ln/>
           <a:effectLst>
@@ -4306,30 +4551,30 @@
       </p:sp>
       <p:sp>
         <p:nvSpPr>
-          <p:cNvPr id="8" name="Text 6"/>
-          <p:cNvSpPr/>
-          <p:nvPr/>
-        </p:nvSpPr>
-        <p:spPr>
-          <a:xfrm>
-            <a:off x="502920" y="1700784"/>
-            <a:ext cx="3931920" cy="1883664"/>
-          </a:xfrm>
-          <a:prstGeom prst="rect">
-            <a:avLst/>
-          </a:prstGeom>
-          <a:noFill/>
-          <a:ln/>
-        </p:spPr>
-        <p:txBody>
-          <a:bodyPr wrap="square" lIns="0" tIns="0" rIns="0" bIns="0" rtlCol="0" anchor="ctr"/>
-          <a:lstStyle/>
-          <a:p>
-            <a:pPr algn="ctr" indent="0" marL="0">
-              <a:buNone/>
-            </a:pPr>
-            <a:r>
-              <a:rPr lang="en-US" sz="1400" dirty="0">
+          <p:cNvPr id="6" name="Text 4"/>
+          <p:cNvSpPr/>
+          <p:nvPr/>
+        </p:nvSpPr>
+        <p:spPr>
+          <a:xfrm>
+            <a:off x="594360" y="1225296"/>
+            <a:ext cx="7863840" cy="402336"/>
+          </a:xfrm>
+          <a:prstGeom prst="rect">
+            <a:avLst/>
+          </a:prstGeom>
+          <a:noFill/>
+          <a:ln/>
+        </p:spPr>
+        <p:txBody>
+          <a:bodyPr wrap="square" lIns="0" tIns="0" rIns="0" bIns="0" rtlCol="0" anchor="ctr"/>
+          <a:lstStyle/>
+          <a:p>
+            <a:pPr indent="0" marL="0">
+              <a:buNone/>
+            </a:pPr>
+            <a:r>
+              <a:rPr lang="en-US" sz="1600" dirty="0">
                 <a:solidFill>
                   <a:srgbClr val="1E293B"/>
                 </a:solidFill>
@@ -4337,138 +4582,26 @@
                 <a:ea typeface="Calibri" pitchFamily="34" charset="-122"/>
                 <a:cs typeface="Calibri" pitchFamily="34" charset="-120"/>
               </a:rPr>
-              <a:t>garlic</a:t>
-            </a:r>
-            <a:endParaRPr lang="en-US" sz="1400" dirty="0"/>
-          </a:p>
-          <a:p>
-            <a:pPr algn="ctr" indent="0" marL="0">
-              <a:buNone/>
-            </a:pPr>
-            <a:r>
-              <a:rPr lang="en-US" sz="1400" dirty="0">
-                <a:solidFill>
-                  <a:srgbClr val="1E293B"/>
-                </a:solidFill>
-                <a:latin typeface="Calibri" pitchFamily="34" charset="0"/>
-                <a:ea typeface="Calibri" pitchFamily="34" charset="-122"/>
-                <a:cs typeface="Calibri" pitchFamily="34" charset="-120"/>
-              </a:rPr>
-              <a:t>gold</a:t>
-            </a:r>
-            <a:endParaRPr lang="en-US" sz="1400" dirty="0"/>
-          </a:p>
-          <a:p>
-            <a:pPr algn="ctr" indent="0" marL="0">
-              <a:buNone/>
-            </a:pPr>
-            <a:r>
-              <a:rPr lang="en-US" sz="1400" dirty="0">
-                <a:solidFill>
-                  <a:srgbClr val="1E293B"/>
-                </a:solidFill>
-                <a:latin typeface="Calibri" pitchFamily="34" charset="0"/>
-                <a:ea typeface="Calibri" pitchFamily="34" charset="-122"/>
-                <a:cs typeface="Calibri" pitchFamily="34" charset="-120"/>
-              </a:rPr>
-              <a:t>candle</a:t>
-            </a:r>
-            <a:endParaRPr lang="en-US" sz="1400" dirty="0"/>
-          </a:p>
-          <a:p>
-            <a:pPr algn="ctr" indent="0" marL="0">
-              <a:buNone/>
-            </a:pPr>
-            <a:r>
-              <a:rPr lang="en-US" sz="1400" dirty="0">
-                <a:solidFill>
-                  <a:srgbClr val="1E293B"/>
-                </a:solidFill>
-                <a:latin typeface="Calibri" pitchFamily="34" charset="0"/>
-                <a:ea typeface="Calibri" pitchFamily="34" charset="-122"/>
-                <a:cs typeface="Calibri" pitchFamily="34" charset="-120"/>
-              </a:rPr>
-              <a:t>Cook</a:t>
-            </a:r>
-            <a:endParaRPr lang="en-US" sz="1400" dirty="0"/>
-          </a:p>
-        </p:txBody>
-      </p:sp>
-      <p:sp>
-        <p:nvSpPr>
-          <p:cNvPr id="9" name="Shape 7"/>
-          <p:cNvSpPr/>
-          <p:nvPr/>
-        </p:nvSpPr>
-        <p:spPr>
-          <a:xfrm>
-            <a:off x="4617720" y="1078992"/>
-            <a:ext cx="4114800" cy="457200"/>
+              <a:t>Despereaux is small. Next to his brothers he looks even ______. (from small )</a:t>
+            </a:r>
+            <a:endParaRPr lang="en-US" sz="1600" dirty="0"/>
+          </a:p>
+        </p:txBody>
+      </p:sp>
+      <p:sp>
+        <p:nvSpPr>
+          <p:cNvPr id="7" name="Shape 5"/>
+          <p:cNvSpPr/>
+          <p:nvPr/>
+        </p:nvSpPr>
+        <p:spPr>
+          <a:xfrm>
+            <a:off x="365760" y="1810512"/>
+            <a:ext cx="8412480" cy="658368"/>
           </a:xfrm>
           <a:prstGeom prst="roundRect">
             <a:avLst>
-              <a:gd name="adj" fmla="val 16000"/>
-            </a:avLst>
-          </a:prstGeom>
-          <a:solidFill>
-            <a:srgbClr val="0E1C42"/>
-          </a:solidFill>
-          <a:ln/>
-        </p:spPr>
-      </p:sp>
-      <p:sp>
-        <p:nvSpPr>
-          <p:cNvPr id="10" name="Text 8"/>
-          <p:cNvSpPr/>
-          <p:nvPr/>
-        </p:nvSpPr>
-        <p:spPr>
-          <a:xfrm>
-            <a:off x="4663440" y="1133856"/>
-            <a:ext cx="4023360" cy="347472"/>
-          </a:xfrm>
-          <a:prstGeom prst="rect">
-            <a:avLst/>
-          </a:prstGeom>
-          <a:noFill/>
-          <a:ln/>
-        </p:spPr>
-        <p:txBody>
-          <a:bodyPr wrap="square" lIns="0" tIns="0" rIns="0" bIns="0" rtlCol="0" anchor="ctr"/>
-          <a:lstStyle/>
-          <a:p>
-            <a:pPr algn="ctr" indent="0" marL="0">
-              <a:buNone/>
-            </a:pPr>
-            <a:r>
-              <a:rPr lang="en-US" sz="1300" b="1" dirty="0">
-                <a:solidFill>
-                  <a:srgbClr val="FFFFFF"/>
-                </a:solidFill>
-                <a:latin typeface="Calibri" pitchFamily="34" charset="0"/>
-                <a:ea typeface="Calibri" pitchFamily="34" charset="-122"/>
-                <a:cs typeface="Calibri" pitchFamily="34" charset="-120"/>
-              </a:rPr>
-              <a:t>Soft (/s/ or /j/)</a:t>
-            </a:r>
-            <a:endParaRPr lang="en-US" sz="1300" dirty="0"/>
-          </a:p>
-        </p:txBody>
-      </p:sp>
-      <p:sp>
-        <p:nvSpPr>
-          <p:cNvPr id="11" name="Shape 9"/>
-          <p:cNvSpPr/>
-          <p:nvPr/>
-        </p:nvSpPr>
-        <p:spPr>
-          <a:xfrm>
-            <a:off x="4617720" y="1591056"/>
-            <a:ext cx="4114800" cy="2103120"/>
-          </a:xfrm>
-          <a:prstGeom prst="roundRect">
-            <a:avLst>
-              <a:gd name="adj" fmla="val 4348"/>
+              <a:gd name="adj" fmla="val 13889"/>
             </a:avLst>
           </a:prstGeom>
           <a:solidFill>
@@ -4486,30 +4619,166 @@
       </p:sp>
       <p:sp>
         <p:nvSpPr>
+          <p:cNvPr id="8" name="Text 6"/>
+          <p:cNvSpPr/>
+          <p:nvPr/>
+        </p:nvSpPr>
+        <p:spPr>
+          <a:xfrm>
+            <a:off x="594360" y="1956816"/>
+            <a:ext cx="7863840" cy="402336"/>
+          </a:xfrm>
+          <a:prstGeom prst="rect">
+            <a:avLst/>
+          </a:prstGeom>
+          <a:noFill/>
+          <a:ln/>
+        </p:spPr>
+        <p:txBody>
+          <a:bodyPr wrap="square" lIns="0" tIns="0" rIns="0" bIns="0" rtlCol="0" anchor="ctr"/>
+          <a:lstStyle/>
+          <a:p>
+            <a:pPr indent="0" marL="0">
+              <a:buNone/>
+            </a:pPr>
+            <a:r>
+              <a:rPr lang="en-US" sz="1600" dirty="0">
+                <a:solidFill>
+                  <a:srgbClr val="1E293B"/>
+                </a:solidFill>
+                <a:latin typeface="Calibri" pitchFamily="34" charset="0"/>
+                <a:ea typeface="Calibri" pitchFamily="34" charset="-122"/>
+                <a:cs typeface="Calibri" pitchFamily="34" charset="-120"/>
+              </a:rPr>
+              <a:t>Of all the mice in the castle, Despereaux is the ______. (from small )</a:t>
+            </a:r>
+            <a:endParaRPr lang="en-US" sz="1600" dirty="0"/>
+          </a:p>
+        </p:txBody>
+      </p:sp>
+      <p:sp>
+        <p:nvSpPr>
+          <p:cNvPr id="9" name="Shape 7"/>
+          <p:cNvSpPr/>
+          <p:nvPr/>
+        </p:nvSpPr>
+        <p:spPr>
+          <a:xfrm>
+            <a:off x="365760" y="2542032"/>
+            <a:ext cx="8412480" cy="658368"/>
+          </a:xfrm>
+          <a:prstGeom prst="roundRect">
+            <a:avLst>
+              <a:gd name="adj" fmla="val 13889"/>
+            </a:avLst>
+          </a:prstGeom>
+          <a:solidFill>
+            <a:srgbClr val="FEF6E8"/>
+          </a:solidFill>
+          <a:ln/>
+          <a:effectLst>
+            <a:outerShdw sx="100000" sy="100000" kx="0" ky="0" algn="bl" rotWithShape="0" blurRad="101600" dist="38100" dir="2700000">
+              <a:srgbClr val="000000">
+                <a:alpha val="12000"/>
+              </a:srgbClr>
+            </a:outerShdw>
+          </a:effectLst>
+        </p:spPr>
+      </p:sp>
+      <p:sp>
+        <p:nvSpPr>
+          <p:cNvPr id="10" name="Text 8"/>
+          <p:cNvSpPr/>
+          <p:nvPr/>
+        </p:nvSpPr>
+        <p:spPr>
+          <a:xfrm>
+            <a:off x="594360" y="2688336"/>
+            <a:ext cx="7863840" cy="402336"/>
+          </a:xfrm>
+          <a:prstGeom prst="rect">
+            <a:avLst/>
+          </a:prstGeom>
+          <a:noFill/>
+          <a:ln/>
+        </p:spPr>
+        <p:txBody>
+          <a:bodyPr wrap="square" lIns="0" tIns="0" rIns="0" bIns="0" rtlCol="0" anchor="ctr"/>
+          <a:lstStyle/>
+          <a:p>
+            <a:pPr indent="0" marL="0">
+              <a:buNone/>
+            </a:pPr>
+            <a:r>
+              <a:rPr lang="en-US" sz="1600" dirty="0">
+                <a:solidFill>
+                  <a:srgbClr val="1E293B"/>
+                </a:solidFill>
+                <a:latin typeface="Calibri" pitchFamily="34" charset="0"/>
+                <a:ea typeface="Calibri" pitchFamily="34" charset="-122"/>
+                <a:cs typeface="Calibri" pitchFamily="34" charset="-120"/>
+              </a:rPr>
+              <a:t>The dungeon is dark. The deep downs are even ______. (from dark )</a:t>
+            </a:r>
+            <a:endParaRPr lang="en-US" sz="1600" dirty="0"/>
+          </a:p>
+        </p:txBody>
+      </p:sp>
+      <p:sp>
+        <p:nvSpPr>
+          <p:cNvPr id="11" name="Shape 9"/>
+          <p:cNvSpPr/>
+          <p:nvPr/>
+        </p:nvSpPr>
+        <p:spPr>
+          <a:xfrm>
+            <a:off x="365760" y="3273552"/>
+            <a:ext cx="8412480" cy="658368"/>
+          </a:xfrm>
+          <a:prstGeom prst="roundRect">
+            <a:avLst>
+              <a:gd name="adj" fmla="val 13889"/>
+            </a:avLst>
+          </a:prstGeom>
+          <a:solidFill>
+            <a:srgbClr val="FFFFFF"/>
+          </a:solidFill>
+          <a:ln/>
+          <a:effectLst>
+            <a:outerShdw sx="100000" sy="100000" kx="0" ky="0" algn="bl" rotWithShape="0" blurRad="101600" dist="38100" dir="2700000">
+              <a:srgbClr val="000000">
+                <a:alpha val="12000"/>
+              </a:srgbClr>
+            </a:outerShdw>
+          </a:effectLst>
+        </p:spPr>
+      </p:sp>
+      <p:sp>
+        <p:nvSpPr>
           <p:cNvPr id="12" name="Text 10"/>
           <p:cNvSpPr/>
           <p:nvPr/>
         </p:nvSpPr>
         <p:spPr>
           <a:xfrm>
-            <a:off x="4709160" y="1700784"/>
-            <a:ext cx="3931920" cy="1883664"/>
-          </a:xfrm>
-          <a:prstGeom prst="rect">
-            <a:avLst/>
-          </a:prstGeom>
-          <a:noFill/>
-          <a:ln/>
-        </p:spPr>
-        <p:txBody>
-          <a:bodyPr wrap="square" lIns="0" tIns="0" rIns="0" bIns="0" rtlCol="0" anchor="ctr"/>
-          <a:lstStyle/>
-          <a:p>
-            <a:pPr algn="ctr" indent="0" marL="0">
-              <a:buNone/>
-            </a:pPr>
-            <a:r>
-              <a:rPr lang="en-US" sz="1400" dirty="0">
+            <a:off x="594360" y="3419856"/>
+            <a:ext cx="7863840" cy="402336"/>
+          </a:xfrm>
+          <a:prstGeom prst="rect">
+            <a:avLst/>
+          </a:prstGeom>
+          <a:noFill/>
+          <a:ln/>
+        </p:spPr>
+        <p:txBody>
+          <a:bodyPr wrap="square" lIns="0" tIns="0" rIns="0" bIns="0" rtlCol="0" anchor="ctr"/>
+          <a:lstStyle/>
+          <a:p>
+            <a:pPr indent="0" marL="0">
+              <a:buNone/>
+            </a:pPr>
+            <a:r>
+              <a:rPr lang="en-US" sz="1600" dirty="0">
                 <a:solidFill>
                   <a:srgbClr val="1E293B"/>
                 </a:solidFill>
@@ -4517,60 +4786,48 @@
                 <a:ea typeface="Calibri" pitchFamily="34" charset="-122"/>
                 <a:cs typeface="Calibri" pitchFamily="34" charset="-120"/>
               </a:rPr>
-              <a:t>gentle</a:t>
-            </a:r>
-            <a:endParaRPr lang="en-US" sz="1400" dirty="0"/>
-          </a:p>
-          <a:p>
-            <a:pPr algn="ctr" indent="0" marL="0">
-              <a:buNone/>
-            </a:pPr>
-            <a:r>
-              <a:rPr lang="en-US" sz="1400" dirty="0">
-                <a:solidFill>
-                  <a:srgbClr val="1E293B"/>
-                </a:solidFill>
-                <a:latin typeface="Calibri" pitchFamily="34" charset="0"/>
-                <a:ea typeface="Calibri" pitchFamily="34" charset="-122"/>
-                <a:cs typeface="Calibri" pitchFamily="34" charset="-120"/>
-              </a:rPr>
-              <a:t>magic</a:t>
-            </a:r>
-            <a:endParaRPr lang="en-US" sz="1400" dirty="0"/>
-          </a:p>
-          <a:p>
-            <a:pPr algn="ctr" indent="0" marL="0">
-              <a:buNone/>
-            </a:pPr>
-            <a:r>
-              <a:rPr lang="en-US" sz="1400" dirty="0">
-                <a:solidFill>
-                  <a:srgbClr val="1E293B"/>
-                </a:solidFill>
-                <a:latin typeface="Calibri" pitchFamily="34" charset="0"/>
-                <a:ea typeface="Calibri" pitchFamily="34" charset="-122"/>
-                <a:cs typeface="Calibri" pitchFamily="34" charset="-120"/>
-              </a:rPr>
-              <a:t>prince</a:t>
-            </a:r>
-            <a:endParaRPr lang="en-US" sz="1400" dirty="0"/>
-          </a:p>
-          <a:p>
-            <a:pPr algn="ctr" indent="0" marL="0">
-              <a:buNone/>
-            </a:pPr>
-            <a:r>
-              <a:rPr lang="en-US" sz="1400" dirty="0">
-                <a:solidFill>
-                  <a:srgbClr val="1E293B"/>
-                </a:solidFill>
-                <a:latin typeface="Calibri" pitchFamily="34" charset="0"/>
-                <a:ea typeface="Calibri" pitchFamily="34" charset="-122"/>
-                <a:cs typeface="Calibri" pitchFamily="34" charset="-120"/>
-              </a:rPr>
-              <a:t>mice</a:t>
-            </a:r>
-            <a:endParaRPr lang="en-US" sz="1400" dirty="0"/>
+              <a:t>Of every room in the castle, the deep downs are the ______. (from dark )</a:t>
+            </a:r>
+            <a:endParaRPr lang="en-US" sz="1600" dirty="0"/>
+          </a:p>
+        </p:txBody>
+      </p:sp>
+      <p:sp>
+        <p:nvSpPr>
+          <p:cNvPr id="13" name="Text 11"/>
+          <p:cNvSpPr/>
+          <p:nvPr/>
+        </p:nvSpPr>
+        <p:spPr>
+          <a:xfrm>
+            <a:off x="365760" y="4050792"/>
+            <a:ext cx="8412480" cy="365760"/>
+          </a:xfrm>
+          <a:prstGeom prst="rect">
+            <a:avLst/>
+          </a:prstGeom>
+          <a:noFill/>
+          <a:ln/>
+        </p:spPr>
+        <p:txBody>
+          <a:bodyPr wrap="square" lIns="0" tIns="0" rIns="0" bIns="0" rtlCol="0" anchor="ctr"/>
+          <a:lstStyle/>
+          <a:p>
+            <a:pPr indent="0" marL="0">
+              <a:buNone/>
+            </a:pPr>
+            <a:r>
+              <a:rPr lang="en-US" sz="1500" i="1" dirty="0">
+                <a:solidFill>
+                  <a:srgbClr val="64748B"/>
+                </a:solidFill>
+                <a:latin typeface="Calibri" pitchFamily="34" charset="0"/>
+                <a:ea typeface="Calibri" pitchFamily="34" charset="-122"/>
+                <a:cs typeface="Calibri" pitchFamily="34" charset="-120"/>
+              </a:rPr>
+              <a:t>Your turn. Type the comparing form that finishes each sentence.</a:t>
+            </a:r>
+            <a:endParaRPr lang="en-US" sz="1500" dirty="0"/>
           </a:p>
         </p:txBody>
       </p:sp>
@@ -4585,6 +4842,840 @@
 <file path=ppt/slides/slide15.xml><?xml version="1.0" encoding="utf-8"?>
 <p:sld xmlns:a="http://schemas.openxmlformats.org/drawingml/2006/main" xmlns:r="http://schemas.openxmlformats.org/officeDocument/2006/relationships" xmlns:p="http://schemas.openxmlformats.org/presentationml/2006/main">
   <p:cSld name="Slide 15">
+    <p:bg>
+      <p:bgPr>
+        <a:solidFill>
+          <a:srgbClr val="F8FAFC"/>
+        </a:solidFill>
+      </p:bgPr>
+    </p:bg>
+    <p:spTree>
+      <p:nvGrpSpPr>
+        <p:cNvPr id="1" name=""/>
+        <p:cNvGrpSpPr/>
+        <p:nvPr/>
+      </p:nvGrpSpPr>
+      <p:grpSpPr>
+        <a:xfrm>
+          <a:off x="0" y="0"/>
+          <a:ext cx="0" cy="0"/>
+          <a:chOff x="0" y="0"/>
+          <a:chExt cx="0" cy="0"/>
+        </a:xfrm>
+      </p:grpSpPr>
+      <p:sp>
+        <p:nvSpPr>
+          <p:cNvPr id="2" name="Shape 0"/>
+          <p:cNvSpPr/>
+          <p:nvPr/>
+        </p:nvSpPr>
+        <p:spPr>
+          <a:xfrm>
+            <a:off x="0" y="0"/>
+            <a:ext cx="9144000" cy="566928"/>
+          </a:xfrm>
+          <a:prstGeom prst="rect">
+            <a:avLst/>
+          </a:prstGeom>
+          <a:solidFill>
+            <a:srgbClr val="C7922C"/>
+          </a:solidFill>
+          <a:ln/>
+        </p:spPr>
+      </p:sp>
+      <p:sp>
+        <p:nvSpPr>
+          <p:cNvPr id="3" name="Text 1"/>
+          <p:cNvSpPr/>
+          <p:nvPr/>
+        </p:nvSpPr>
+        <p:spPr>
+          <a:xfrm>
+            <a:off x="365760" y="54864"/>
+            <a:ext cx="8412480" cy="457200"/>
+          </a:xfrm>
+          <a:prstGeom prst="rect">
+            <a:avLst/>
+          </a:prstGeom>
+          <a:noFill/>
+          <a:ln/>
+        </p:spPr>
+        <p:txBody>
+          <a:bodyPr wrap="square" lIns="0" tIns="0" rIns="0" bIns="0" rtlCol="0" anchor="ctr"/>
+          <a:lstStyle/>
+          <a:p>
+            <a:pPr indent="0" marL="0">
+              <a:buNone/>
+            </a:pPr>
+            <a:r>
+              <a:rPr lang="en-US" sz="2200" b="1" dirty="0">
+                <a:solidFill>
+                  <a:srgbClr val="FFFFFF"/>
+                </a:solidFill>
+                <a:latin typeface="Calibri" pitchFamily="34" charset="0"/>
+                <a:ea typeface="Calibri" pitchFamily="34" charset="-122"/>
+                <a:cs typeface="Calibri" pitchFamily="34" charset="-120"/>
+              </a:rPr>
+              <a:t>✏️  Grammar</a:t>
+            </a:r>
+            <a:endParaRPr lang="en-US" sz="2200" dirty="0"/>
+          </a:p>
+        </p:txBody>
+      </p:sp>
+      <p:sp>
+        <p:nvSpPr>
+          <p:cNvPr id="4" name="Text 2"/>
+          <p:cNvSpPr/>
+          <p:nvPr/>
+        </p:nvSpPr>
+        <p:spPr>
+          <a:xfrm>
+            <a:off x="365760" y="777240"/>
+            <a:ext cx="8229600" cy="237744"/>
+          </a:xfrm>
+          <a:prstGeom prst="rect">
+            <a:avLst/>
+          </a:prstGeom>
+          <a:noFill/>
+          <a:ln/>
+        </p:spPr>
+        <p:txBody>
+          <a:bodyPr wrap="square" lIns="0" tIns="0" rIns="0" bIns="0" rtlCol="0" anchor="ctr"/>
+          <a:lstStyle/>
+          <a:p>
+            <a:pPr indent="0" marL="0">
+              <a:buNone/>
+            </a:pPr>
+            <a:r>
+              <a:rPr lang="en-US" sz="1100" b="1" spc="100" kern="0" dirty="0">
+                <a:solidFill>
+                  <a:srgbClr val="C7922C"/>
+                </a:solidFill>
+                <a:latin typeface="Calibri" pitchFamily="34" charset="0"/>
+                <a:ea typeface="Calibri" pitchFamily="34" charset="-122"/>
+                <a:cs typeface="Calibri" pitchFamily="34" charset="-120"/>
+              </a:rPr>
+              <a:t>ADJECTIVES AND COMPARING</a:t>
+            </a:r>
+            <a:endParaRPr lang="en-US" sz="1100" dirty="0"/>
+          </a:p>
+        </p:txBody>
+      </p:sp>
+      <p:sp>
+        <p:nvSpPr>
+          <p:cNvPr id="5" name="Shape 3"/>
+          <p:cNvSpPr/>
+          <p:nvPr/>
+        </p:nvSpPr>
+        <p:spPr>
+          <a:xfrm>
+            <a:off x="365760" y="1078992"/>
+            <a:ext cx="8412480" cy="658368"/>
+          </a:xfrm>
+          <a:prstGeom prst="roundRect">
+            <a:avLst>
+              <a:gd name="adj" fmla="val 13889"/>
+            </a:avLst>
+          </a:prstGeom>
+          <a:solidFill>
+            <a:srgbClr val="FEF6E8"/>
+          </a:solidFill>
+          <a:ln/>
+          <a:effectLst>
+            <a:outerShdw sx="100000" sy="100000" kx="0" ky="0" algn="bl" rotWithShape="0" blurRad="101600" dist="38100" dir="2700000">
+              <a:srgbClr val="000000">
+                <a:alpha val="12000"/>
+              </a:srgbClr>
+            </a:outerShdw>
+          </a:effectLst>
+        </p:spPr>
+      </p:sp>
+      <p:sp>
+        <p:nvSpPr>
+          <p:cNvPr id="6" name="Text 4"/>
+          <p:cNvSpPr/>
+          <p:nvPr/>
+        </p:nvSpPr>
+        <p:spPr>
+          <a:xfrm>
+            <a:off x="594360" y="1225296"/>
+            <a:ext cx="7863840" cy="402336"/>
+          </a:xfrm>
+          <a:prstGeom prst="rect">
+            <a:avLst/>
+          </a:prstGeom>
+          <a:noFill/>
+          <a:ln/>
+        </p:spPr>
+        <p:txBody>
+          <a:bodyPr wrap="square" lIns="0" tIns="0" rIns="0" bIns="0" rtlCol="0" anchor="ctr"/>
+          <a:lstStyle/>
+          <a:p>
+            <a:pPr indent="0" marL="0">
+              <a:buNone/>
+            </a:pPr>
+            <a:r>
+              <a:rPr lang="en-US" sz="1600" dirty="0">
+                <a:solidFill>
+                  <a:srgbClr val="1E293B"/>
+                </a:solidFill>
+                <a:latin typeface="Calibri" pitchFamily="34" charset="0"/>
+                <a:ea typeface="Calibri" pitchFamily="34" charset="-122"/>
+                <a:cs typeface="Calibri" pitchFamily="34" charset="-120"/>
+              </a:rPr>
+              <a:t>Despereaux is small. Next to his brothers he looks even </a:t>
+            </a:r>
+            <a:pPr indent="0" marL="0">
+              <a:buNone/>
+            </a:pPr>
+            <a:r>
+              <a:rPr lang="en-US" sz="1600" b="1" dirty="0">
+                <a:solidFill>
+                  <a:srgbClr val="34B76F"/>
+                </a:solidFill>
+                <a:latin typeface="Calibri" pitchFamily="34" charset="0"/>
+                <a:ea typeface="Calibri" pitchFamily="34" charset="-122"/>
+                <a:cs typeface="Calibri" pitchFamily="34" charset="-120"/>
+              </a:rPr>
+              <a:t>smaller</a:t>
+            </a:r>
+            <a:pPr indent="0" marL="0">
+              <a:buNone/>
+            </a:pPr>
+            <a:r>
+              <a:rPr lang="en-US" sz="1600" dirty="0">
+                <a:solidFill>
+                  <a:srgbClr val="1E293B"/>
+                </a:solidFill>
+                <a:latin typeface="Calibri" pitchFamily="34" charset="0"/>
+                <a:ea typeface="Calibri" pitchFamily="34" charset="-122"/>
+                <a:cs typeface="Calibri" pitchFamily="34" charset="-120"/>
+              </a:rPr>
+              <a:t>. (from small )</a:t>
+            </a:r>
+            <a:endParaRPr lang="en-US" sz="1600" dirty="0"/>
+          </a:p>
+        </p:txBody>
+      </p:sp>
+      <p:sp>
+        <p:nvSpPr>
+          <p:cNvPr id="7" name="Shape 5"/>
+          <p:cNvSpPr/>
+          <p:nvPr/>
+        </p:nvSpPr>
+        <p:spPr>
+          <a:xfrm>
+            <a:off x="365760" y="1810512"/>
+            <a:ext cx="8412480" cy="658368"/>
+          </a:xfrm>
+          <a:prstGeom prst="roundRect">
+            <a:avLst>
+              <a:gd name="adj" fmla="val 13889"/>
+            </a:avLst>
+          </a:prstGeom>
+          <a:solidFill>
+            <a:srgbClr val="FFFFFF"/>
+          </a:solidFill>
+          <a:ln/>
+          <a:effectLst>
+            <a:outerShdw sx="100000" sy="100000" kx="0" ky="0" algn="bl" rotWithShape="0" blurRad="101600" dist="38100" dir="2700000">
+              <a:srgbClr val="000000">
+                <a:alpha val="12000"/>
+              </a:srgbClr>
+            </a:outerShdw>
+          </a:effectLst>
+        </p:spPr>
+      </p:sp>
+      <p:sp>
+        <p:nvSpPr>
+          <p:cNvPr id="8" name="Text 6"/>
+          <p:cNvSpPr/>
+          <p:nvPr/>
+        </p:nvSpPr>
+        <p:spPr>
+          <a:xfrm>
+            <a:off x="594360" y="1956816"/>
+            <a:ext cx="7863840" cy="402336"/>
+          </a:xfrm>
+          <a:prstGeom prst="rect">
+            <a:avLst/>
+          </a:prstGeom>
+          <a:noFill/>
+          <a:ln/>
+        </p:spPr>
+        <p:txBody>
+          <a:bodyPr wrap="square" lIns="0" tIns="0" rIns="0" bIns="0" rtlCol="0" anchor="ctr"/>
+          <a:lstStyle/>
+          <a:p>
+            <a:pPr indent="0" marL="0">
+              <a:buNone/>
+            </a:pPr>
+            <a:r>
+              <a:rPr lang="en-US" sz="1600" dirty="0">
+                <a:solidFill>
+                  <a:srgbClr val="1E293B"/>
+                </a:solidFill>
+                <a:latin typeface="Calibri" pitchFamily="34" charset="0"/>
+                <a:ea typeface="Calibri" pitchFamily="34" charset="-122"/>
+                <a:cs typeface="Calibri" pitchFamily="34" charset="-120"/>
+              </a:rPr>
+              <a:t>Of all the mice in the castle, Despereaux is the </a:t>
+            </a:r>
+            <a:pPr indent="0" marL="0">
+              <a:buNone/>
+            </a:pPr>
+            <a:r>
+              <a:rPr lang="en-US" sz="1600" b="1" dirty="0">
+                <a:solidFill>
+                  <a:srgbClr val="34B76F"/>
+                </a:solidFill>
+                <a:latin typeface="Calibri" pitchFamily="34" charset="0"/>
+                <a:ea typeface="Calibri" pitchFamily="34" charset="-122"/>
+                <a:cs typeface="Calibri" pitchFamily="34" charset="-120"/>
+              </a:rPr>
+              <a:t>smallest</a:t>
+            </a:r>
+            <a:pPr indent="0" marL="0">
+              <a:buNone/>
+            </a:pPr>
+            <a:r>
+              <a:rPr lang="en-US" sz="1600" dirty="0">
+                <a:solidFill>
+                  <a:srgbClr val="1E293B"/>
+                </a:solidFill>
+                <a:latin typeface="Calibri" pitchFamily="34" charset="0"/>
+                <a:ea typeface="Calibri" pitchFamily="34" charset="-122"/>
+                <a:cs typeface="Calibri" pitchFamily="34" charset="-120"/>
+              </a:rPr>
+              <a:t>. (from small )</a:t>
+            </a:r>
+            <a:endParaRPr lang="en-US" sz="1600" dirty="0"/>
+          </a:p>
+        </p:txBody>
+      </p:sp>
+      <p:sp>
+        <p:nvSpPr>
+          <p:cNvPr id="9" name="Shape 7"/>
+          <p:cNvSpPr/>
+          <p:nvPr/>
+        </p:nvSpPr>
+        <p:spPr>
+          <a:xfrm>
+            <a:off x="365760" y="2542032"/>
+            <a:ext cx="8412480" cy="658368"/>
+          </a:xfrm>
+          <a:prstGeom prst="roundRect">
+            <a:avLst>
+              <a:gd name="adj" fmla="val 13889"/>
+            </a:avLst>
+          </a:prstGeom>
+          <a:solidFill>
+            <a:srgbClr val="FEF6E8"/>
+          </a:solidFill>
+          <a:ln/>
+          <a:effectLst>
+            <a:outerShdw sx="100000" sy="100000" kx="0" ky="0" algn="bl" rotWithShape="0" blurRad="101600" dist="38100" dir="2700000">
+              <a:srgbClr val="000000">
+                <a:alpha val="12000"/>
+              </a:srgbClr>
+            </a:outerShdw>
+          </a:effectLst>
+        </p:spPr>
+      </p:sp>
+      <p:sp>
+        <p:nvSpPr>
+          <p:cNvPr id="10" name="Text 8"/>
+          <p:cNvSpPr/>
+          <p:nvPr/>
+        </p:nvSpPr>
+        <p:spPr>
+          <a:xfrm>
+            <a:off x="594360" y="2688336"/>
+            <a:ext cx="7863840" cy="402336"/>
+          </a:xfrm>
+          <a:prstGeom prst="rect">
+            <a:avLst/>
+          </a:prstGeom>
+          <a:noFill/>
+          <a:ln/>
+        </p:spPr>
+        <p:txBody>
+          <a:bodyPr wrap="square" lIns="0" tIns="0" rIns="0" bIns="0" rtlCol="0" anchor="ctr"/>
+          <a:lstStyle/>
+          <a:p>
+            <a:pPr indent="0" marL="0">
+              <a:buNone/>
+            </a:pPr>
+            <a:r>
+              <a:rPr lang="en-US" sz="1600" dirty="0">
+                <a:solidFill>
+                  <a:srgbClr val="1E293B"/>
+                </a:solidFill>
+                <a:latin typeface="Calibri" pitchFamily="34" charset="0"/>
+                <a:ea typeface="Calibri" pitchFamily="34" charset="-122"/>
+                <a:cs typeface="Calibri" pitchFamily="34" charset="-120"/>
+              </a:rPr>
+              <a:t>The dungeon is dark. The deep downs are even </a:t>
+            </a:r>
+            <a:pPr indent="0" marL="0">
+              <a:buNone/>
+            </a:pPr>
+            <a:r>
+              <a:rPr lang="en-US" sz="1600" b="1" dirty="0">
+                <a:solidFill>
+                  <a:srgbClr val="34B76F"/>
+                </a:solidFill>
+                <a:latin typeface="Calibri" pitchFamily="34" charset="0"/>
+                <a:ea typeface="Calibri" pitchFamily="34" charset="-122"/>
+                <a:cs typeface="Calibri" pitchFamily="34" charset="-120"/>
+              </a:rPr>
+              <a:t>darker</a:t>
+            </a:r>
+            <a:pPr indent="0" marL="0">
+              <a:buNone/>
+            </a:pPr>
+            <a:r>
+              <a:rPr lang="en-US" sz="1600" dirty="0">
+                <a:solidFill>
+                  <a:srgbClr val="1E293B"/>
+                </a:solidFill>
+                <a:latin typeface="Calibri" pitchFamily="34" charset="0"/>
+                <a:ea typeface="Calibri" pitchFamily="34" charset="-122"/>
+                <a:cs typeface="Calibri" pitchFamily="34" charset="-120"/>
+              </a:rPr>
+              <a:t>. (from dark )</a:t>
+            </a:r>
+            <a:endParaRPr lang="en-US" sz="1600" dirty="0"/>
+          </a:p>
+        </p:txBody>
+      </p:sp>
+      <p:sp>
+        <p:nvSpPr>
+          <p:cNvPr id="11" name="Shape 9"/>
+          <p:cNvSpPr/>
+          <p:nvPr/>
+        </p:nvSpPr>
+        <p:spPr>
+          <a:xfrm>
+            <a:off x="365760" y="3273552"/>
+            <a:ext cx="8412480" cy="658368"/>
+          </a:xfrm>
+          <a:prstGeom prst="roundRect">
+            <a:avLst>
+              <a:gd name="adj" fmla="val 13889"/>
+            </a:avLst>
+          </a:prstGeom>
+          <a:solidFill>
+            <a:srgbClr val="FFFFFF"/>
+          </a:solidFill>
+          <a:ln/>
+          <a:effectLst>
+            <a:outerShdw sx="100000" sy="100000" kx="0" ky="0" algn="bl" rotWithShape="0" blurRad="101600" dist="38100" dir="2700000">
+              <a:srgbClr val="000000">
+                <a:alpha val="12000"/>
+              </a:srgbClr>
+            </a:outerShdw>
+          </a:effectLst>
+        </p:spPr>
+      </p:sp>
+      <p:sp>
+        <p:nvSpPr>
+          <p:cNvPr id="12" name="Text 10"/>
+          <p:cNvSpPr/>
+          <p:nvPr/>
+        </p:nvSpPr>
+        <p:spPr>
+          <a:xfrm>
+            <a:off x="594360" y="3419856"/>
+            <a:ext cx="7863840" cy="402336"/>
+          </a:xfrm>
+          <a:prstGeom prst="rect">
+            <a:avLst/>
+          </a:prstGeom>
+          <a:noFill/>
+          <a:ln/>
+        </p:spPr>
+        <p:txBody>
+          <a:bodyPr wrap="square" lIns="0" tIns="0" rIns="0" bIns="0" rtlCol="0" anchor="ctr"/>
+          <a:lstStyle/>
+          <a:p>
+            <a:pPr indent="0" marL="0">
+              <a:buNone/>
+            </a:pPr>
+            <a:r>
+              <a:rPr lang="en-US" sz="1600" dirty="0">
+                <a:solidFill>
+                  <a:srgbClr val="1E293B"/>
+                </a:solidFill>
+                <a:latin typeface="Calibri" pitchFamily="34" charset="0"/>
+                <a:ea typeface="Calibri" pitchFamily="34" charset="-122"/>
+                <a:cs typeface="Calibri" pitchFamily="34" charset="-120"/>
+              </a:rPr>
+              <a:t>Of every room in the castle, the deep downs are the </a:t>
+            </a:r>
+            <a:pPr indent="0" marL="0">
+              <a:buNone/>
+            </a:pPr>
+            <a:r>
+              <a:rPr lang="en-US" sz="1600" b="1" dirty="0">
+                <a:solidFill>
+                  <a:srgbClr val="34B76F"/>
+                </a:solidFill>
+                <a:latin typeface="Calibri" pitchFamily="34" charset="0"/>
+                <a:ea typeface="Calibri" pitchFamily="34" charset="-122"/>
+                <a:cs typeface="Calibri" pitchFamily="34" charset="-120"/>
+              </a:rPr>
+              <a:t>darkest</a:t>
+            </a:r>
+            <a:pPr indent="0" marL="0">
+              <a:buNone/>
+            </a:pPr>
+            <a:r>
+              <a:rPr lang="en-US" sz="1600" dirty="0">
+                <a:solidFill>
+                  <a:srgbClr val="1E293B"/>
+                </a:solidFill>
+                <a:latin typeface="Calibri" pitchFamily="34" charset="0"/>
+                <a:ea typeface="Calibri" pitchFamily="34" charset="-122"/>
+                <a:cs typeface="Calibri" pitchFamily="34" charset="-120"/>
+              </a:rPr>
+              <a:t>. (from dark )</a:t>
+            </a:r>
+            <a:endParaRPr lang="en-US" sz="1600" dirty="0"/>
+          </a:p>
+        </p:txBody>
+      </p:sp>
+      <p:sp>
+        <p:nvSpPr>
+          <p:cNvPr id="13" name="Text 11"/>
+          <p:cNvSpPr/>
+          <p:nvPr/>
+        </p:nvSpPr>
+        <p:spPr>
+          <a:xfrm>
+            <a:off x="365760" y="4050792"/>
+            <a:ext cx="8412480" cy="365760"/>
+          </a:xfrm>
+          <a:prstGeom prst="rect">
+            <a:avLst/>
+          </a:prstGeom>
+          <a:noFill/>
+          <a:ln/>
+        </p:spPr>
+        <p:txBody>
+          <a:bodyPr wrap="square" lIns="0" tIns="0" rIns="0" bIns="0" rtlCol="0" anchor="ctr"/>
+          <a:lstStyle/>
+          <a:p>
+            <a:pPr indent="0" marL="0">
+              <a:buNone/>
+            </a:pPr>
+            <a:r>
+              <a:rPr lang="en-US" sz="1500" b="1" dirty="0">
+                <a:solidFill>
+                  <a:srgbClr val="34B76F"/>
+                </a:solidFill>
+                <a:latin typeface="Calibri" pitchFamily="34" charset="0"/>
+                <a:ea typeface="Calibri" pitchFamily="34" charset="-122"/>
+                <a:cs typeface="Calibri" pitchFamily="34" charset="-120"/>
+              </a:rPr>
+              <a:t>✅  Answers revealed</a:t>
+            </a:r>
+            <a:endParaRPr lang="en-US" sz="1500" dirty="0"/>
+          </a:p>
+        </p:txBody>
+      </p:sp>
+    </p:spTree>
+  </p:cSld>
+  <p:clrMapOvr>
+    <a:masterClrMapping/>
+  </p:clrMapOvr>
+</p:sld>
+</file>
+
+<file path=ppt/slides/slide16.xml><?xml version="1.0" encoding="utf-8"?>
+<p:sld xmlns:a="http://schemas.openxmlformats.org/drawingml/2006/main" xmlns:r="http://schemas.openxmlformats.org/officeDocument/2006/relationships" xmlns:p="http://schemas.openxmlformats.org/presentationml/2006/main">
+  <p:cSld name="Slide 16">
+    <p:bg>
+      <p:bgPr>
+        <a:solidFill>
+          <a:srgbClr val="F8FAFC"/>
+        </a:solidFill>
+      </p:bgPr>
+    </p:bg>
+    <p:spTree>
+      <p:nvGrpSpPr>
+        <p:cNvPr id="1" name=""/>
+        <p:cNvGrpSpPr/>
+        <p:nvPr/>
+      </p:nvGrpSpPr>
+      <p:grpSpPr>
+        <a:xfrm>
+          <a:off x="0" y="0"/>
+          <a:ext cx="0" cy="0"/>
+          <a:chOff x="0" y="0"/>
+          <a:chExt cx="0" cy="0"/>
+        </a:xfrm>
+      </p:grpSpPr>
+      <p:sp>
+        <p:nvSpPr>
+          <p:cNvPr id="2" name="Shape 0"/>
+          <p:cNvSpPr/>
+          <p:nvPr/>
+        </p:nvSpPr>
+        <p:spPr>
+          <a:xfrm>
+            <a:off x="0" y="0"/>
+            <a:ext cx="9144000" cy="566928"/>
+          </a:xfrm>
+          <a:prstGeom prst="rect">
+            <a:avLst/>
+          </a:prstGeom>
+          <a:solidFill>
+            <a:srgbClr val="0E1C42"/>
+          </a:solidFill>
+          <a:ln/>
+        </p:spPr>
+      </p:sp>
+      <p:sp>
+        <p:nvSpPr>
+          <p:cNvPr id="3" name="Text 1"/>
+          <p:cNvSpPr/>
+          <p:nvPr/>
+        </p:nvSpPr>
+        <p:spPr>
+          <a:xfrm>
+            <a:off x="365760" y="54864"/>
+            <a:ext cx="8412480" cy="457200"/>
+          </a:xfrm>
+          <a:prstGeom prst="rect">
+            <a:avLst/>
+          </a:prstGeom>
+          <a:noFill/>
+          <a:ln/>
+        </p:spPr>
+        <p:txBody>
+          <a:bodyPr wrap="square" lIns="0" tIns="0" rIns="0" bIns="0" rtlCol="0" anchor="ctr"/>
+          <a:lstStyle/>
+          <a:p>
+            <a:pPr indent="0" marL="0">
+              <a:buNone/>
+            </a:pPr>
+            <a:r>
+              <a:rPr lang="en-US" sz="2200" b="1" dirty="0">
+                <a:solidFill>
+                  <a:srgbClr val="FFFFFF"/>
+                </a:solidFill>
+                <a:latin typeface="Calibri" pitchFamily="34" charset="0"/>
+                <a:ea typeface="Calibri" pitchFamily="34" charset="-122"/>
+                <a:cs typeface="Calibri" pitchFamily="34" charset="-120"/>
+              </a:rPr>
+              <a:t>🔠  Spelling</a:t>
+            </a:r>
+            <a:endParaRPr lang="en-US" sz="2200" dirty="0"/>
+          </a:p>
+        </p:txBody>
+      </p:sp>
+      <p:sp>
+        <p:nvSpPr>
+          <p:cNvPr id="4" name="Text 2"/>
+          <p:cNvSpPr/>
+          <p:nvPr/>
+        </p:nvSpPr>
+        <p:spPr>
+          <a:xfrm>
+            <a:off x="365760" y="777240"/>
+            <a:ext cx="8229600" cy="237744"/>
+          </a:xfrm>
+          <a:prstGeom prst="rect">
+            <a:avLst/>
+          </a:prstGeom>
+          <a:noFill/>
+          <a:ln/>
+        </p:spPr>
+        <p:txBody>
+          <a:bodyPr wrap="square" lIns="0" tIns="0" rIns="0" bIns="0" rtlCol="0" anchor="ctr"/>
+          <a:lstStyle/>
+          <a:p>
+            <a:pPr indent="0" marL="0">
+              <a:buNone/>
+            </a:pPr>
+            <a:r>
+              <a:rPr lang="en-US" sz="1100" b="1" spc="100" kern="0" dirty="0">
+                <a:solidFill>
+                  <a:srgbClr val="0E1C42"/>
+                </a:solidFill>
+                <a:latin typeface="Calibri" pitchFamily="34" charset="0"/>
+                <a:ea typeface="Calibri" pitchFamily="34" charset="-122"/>
+                <a:cs typeface="Calibri" pitchFamily="34" charset="-120"/>
+              </a:rPr>
+              <a:t>CLOSED SYLLABLES</a:t>
+            </a:r>
+            <a:endParaRPr lang="en-US" sz="1100" dirty="0"/>
+          </a:p>
+        </p:txBody>
+      </p:sp>
+      <p:sp>
+        <p:nvSpPr>
+          <p:cNvPr id="5" name="Text 3"/>
+          <p:cNvSpPr/>
+          <p:nvPr/>
+        </p:nvSpPr>
+        <p:spPr>
+          <a:xfrm>
+            <a:off x="365760" y="1051560"/>
+            <a:ext cx="8229600" cy="237744"/>
+          </a:xfrm>
+          <a:prstGeom prst="rect">
+            <a:avLst/>
+          </a:prstGeom>
+          <a:noFill/>
+          <a:ln/>
+        </p:spPr>
+        <p:txBody>
+          <a:bodyPr wrap="square" lIns="0" tIns="0" rIns="0" bIns="0" rtlCol="0" anchor="ctr"/>
+          <a:lstStyle/>
+          <a:p>
+            <a:pPr indent="0" marL="0">
+              <a:buNone/>
+            </a:pPr>
+            <a:r>
+              <a:rPr lang="en-US" sz="1100" b="1" spc="100" kern="0" dirty="0">
+                <a:solidFill>
+                  <a:srgbClr val="C7922C"/>
+                </a:solidFill>
+                <a:latin typeface="Calibri" pitchFamily="34" charset="0"/>
+                <a:ea typeface="Calibri" pitchFamily="34" charset="-122"/>
+                <a:cs typeface="Calibri" pitchFamily="34" charset="-120"/>
+              </a:rPr>
+              <a:t>📖  THE RULE</a:t>
+            </a:r>
+            <a:endParaRPr lang="en-US" sz="1100" dirty="0"/>
+          </a:p>
+        </p:txBody>
+      </p:sp>
+      <p:sp>
+        <p:nvSpPr>
+          <p:cNvPr id="6" name="Shape 4"/>
+          <p:cNvSpPr/>
+          <p:nvPr/>
+        </p:nvSpPr>
+        <p:spPr>
+          <a:xfrm>
+            <a:off x="365760" y="1298448"/>
+            <a:ext cx="8412480" cy="960120"/>
+          </a:xfrm>
+          <a:prstGeom prst="roundRect">
+            <a:avLst>
+              <a:gd name="adj" fmla="val 9524"/>
+            </a:avLst>
+          </a:prstGeom>
+          <a:solidFill>
+            <a:srgbClr val="FEF6E8"/>
+          </a:solidFill>
+          <a:ln w="19050">
+            <a:solidFill>
+              <a:srgbClr val="C7922C"/>
+            </a:solidFill>
+            <a:prstDash val="solid"/>
+          </a:ln>
+          <a:effectLst>
+            <a:outerShdw sx="100000" sy="100000" kx="0" ky="0" algn="bl" rotWithShape="0" blurRad="101600" dist="38100" dir="2700000">
+              <a:srgbClr val="000000">
+                <a:alpha val="12000"/>
+              </a:srgbClr>
+            </a:outerShdw>
+          </a:effectLst>
+        </p:spPr>
+      </p:sp>
+      <p:sp>
+        <p:nvSpPr>
+          <p:cNvPr id="7" name="Text 5"/>
+          <p:cNvSpPr/>
+          <p:nvPr/>
+        </p:nvSpPr>
+        <p:spPr>
+          <a:xfrm>
+            <a:off x="594360" y="1426464"/>
+            <a:ext cx="7955280" cy="704088"/>
+          </a:xfrm>
+          <a:prstGeom prst="rect">
+            <a:avLst/>
+          </a:prstGeom>
+          <a:noFill/>
+          <a:ln/>
+        </p:spPr>
+        <p:txBody>
+          <a:bodyPr wrap="square" lIns="0" tIns="0" rIns="0" bIns="0" rtlCol="0" anchor="ctr"/>
+          <a:lstStyle/>
+          <a:p>
+            <a:pPr indent="0" marL="0">
+              <a:buNone/>
+            </a:pPr>
+            <a:r>
+              <a:rPr lang="en-US" sz="1700" dirty="0">
+                <a:solidFill>
+                  <a:srgbClr val="1E293B"/>
+                </a:solidFill>
+                <a:latin typeface="Calibri" pitchFamily="34" charset="0"/>
+                <a:ea typeface="Calibri" pitchFamily="34" charset="-122"/>
+                <a:cs typeface="Calibri" pitchFamily="34" charset="-120"/>
+              </a:rPr>
+              <a:t>A closed syllable ends in a consonant, and that consonant shuts the vowel in so it stays short: nap, kin. Long words are often just two closed syllables stuck together: nap·kin.</a:t>
+            </a:r>
+            <a:endParaRPr lang="en-US" sz="1700" dirty="0"/>
+          </a:p>
+        </p:txBody>
+      </p:sp>
+      <p:sp>
+        <p:nvSpPr>
+          <p:cNvPr id="8" name="Text 6"/>
+          <p:cNvSpPr/>
+          <p:nvPr/>
+        </p:nvSpPr>
+        <p:spPr>
+          <a:xfrm>
+            <a:off x="365760" y="2395728"/>
+            <a:ext cx="8412480" cy="411480"/>
+          </a:xfrm>
+          <a:prstGeom prst="rect">
+            <a:avLst/>
+          </a:prstGeom>
+          <a:noFill/>
+          <a:ln/>
+        </p:spPr>
+        <p:txBody>
+          <a:bodyPr wrap="square" lIns="0" tIns="0" rIns="0" bIns="0" rtlCol="0" anchor="ctr"/>
+          <a:lstStyle/>
+          <a:p>
+            <a:pPr indent="0" marL="0">
+              <a:buNone/>
+            </a:pPr>
+            <a:r>
+              <a:rPr lang="en-US" sz="1400" i="1" dirty="0">
+                <a:solidFill>
+                  <a:srgbClr val="64748B"/>
+                </a:solidFill>
+                <a:latin typeface="Calibri" pitchFamily="34" charset="0"/>
+                <a:ea typeface="Calibri" pitchFamily="34" charset="-122"/>
+                <a:cs typeface="Calibri" pitchFamily="34" charset="-120"/>
+              </a:rPr>
+              <a:t>Syllable Tiles! Every one of these is two closed syllables. Tap the chunks in order to build the word. A chunk in the wrong place will not stick.</a:t>
+            </a:r>
+            <a:endParaRPr lang="en-US" sz="1400" dirty="0"/>
+          </a:p>
+        </p:txBody>
+      </p:sp>
+    </p:spTree>
+  </p:cSld>
+  <p:clrMapOvr>
+    <a:masterClrMapping/>
+  </p:clrMapOvr>
+</p:sld>
+</file>
+
+<file path=ppt/slides/slide17.xml><?xml version="1.0" encoding="utf-8"?>
+<p:sld xmlns:a="http://schemas.openxmlformats.org/drawingml/2006/main" xmlns:r="http://schemas.openxmlformats.org/officeDocument/2006/relationships" xmlns:p="http://schemas.openxmlformats.org/presentationml/2006/main">
+  <p:cSld name="Slide 17">
     <p:bg>
       <p:bgPr>
         <a:solidFill>
@@ -4919,9 +6010,9 @@
 </p:sld>
 </file>
 
-<file path=ppt/slides/slide16.xml><?xml version="1.0" encoding="utf-8"?>
+<file path=ppt/slides/slide18.xml><?xml version="1.0" encoding="utf-8"?>
 <p:sld xmlns:a="http://schemas.openxmlformats.org/drawingml/2006/main" xmlns:r="http://schemas.openxmlformats.org/officeDocument/2006/relationships" xmlns:p="http://schemas.openxmlformats.org/presentationml/2006/main">
-  <p:cSld name="Slide 16">
+  <p:cSld name="Slide 18">
     <p:bg>
       <p:bgPr>
         <a:solidFill>
@@ -6459,7 +7550,7 @@
                 <a:ea typeface="Calibri" pitchFamily="34" charset="-122"/>
                 <a:cs typeface="Calibri" pitchFamily="34" charset="-120"/>
               </a:rPr>
-              <a:t>Good readers look for theme clues . A theme is a lesson the whole story teaches.</a:t>
+              <a:t>Good readers look for theme clues. A theme is a lesson the whole story teaches.</a:t>
             </a:r>
             <a:endParaRPr lang="en-US" sz="1500" dirty="0"/>
           </a:p>
@@ -6479,7 +7570,7 @@
     <p:bg>
       <p:bgPr>
         <a:solidFill>
-          <a:srgbClr val="F8FAFC"/>
+          <a:srgbClr val="FFFFFF"/>
         </a:solidFill>
       </p:bgPr>
     </p:bg>
@@ -6564,7 +7655,7 @@
         </p:nvSpPr>
         <p:spPr>
           <a:xfrm>
-            <a:off x="365760" y="749808"/>
+            <a:off x="365760" y="804672"/>
             <a:ext cx="8229600" cy="237744"/>
           </a:xfrm>
           <a:prstGeom prst="rect">
@@ -6589,7 +7680,7 @@
                 <a:ea typeface="Calibri" pitchFamily="34" charset="-122"/>
                 <a:cs typeface="Calibri" pitchFamily="34" charset="-120"/>
               </a:rPr>
-              <a:t>FIX THESE SENTENCES</a:t>
+              <a:t>CORRECT MODEL — STUDY WHAT IS RIGHT</a:t>
             </a:r>
             <a:endParaRPr lang="en-US" sz="1100" dirty="0"/>
           </a:p>
@@ -6603,16 +7694,16 @@
         </p:nvSpPr>
         <p:spPr>
           <a:xfrm>
-            <a:off x="365760" y="1024128"/>
-            <a:ext cx="8412480" cy="777240"/>
+            <a:off x="365760" y="1078992"/>
+            <a:ext cx="8412480" cy="822960"/>
           </a:xfrm>
           <a:prstGeom prst="roundRect">
             <a:avLst>
-              <a:gd name="adj" fmla="val 11765"/>
+              <a:gd name="adj" fmla="val 11111"/>
             </a:avLst>
           </a:prstGeom>
           <a:solidFill>
-            <a:srgbClr val="FFFFFF"/>
+            <a:srgbClr val="E5F7FC"/>
           </a:solidFill>
           <a:ln w="19050">
             <a:solidFill>
@@ -6637,8 +7728,8 @@
         </p:nvSpPr>
         <p:spPr>
           <a:xfrm>
-            <a:off x="594360" y="1152144"/>
-            <a:ext cx="7955280" cy="521208"/>
+            <a:off x="594360" y="1207008"/>
+            <a:ext cx="7955280" cy="566928"/>
           </a:xfrm>
           <a:prstGeom prst="rect">
             <a:avLst/>
@@ -6662,7 +7753,7 @@
                 <a:ea typeface="Calibri" pitchFamily="34" charset="-122"/>
                 <a:cs typeface="Calibri" pitchFamily="34" charset="-120"/>
               </a:rPr>
-              <a:t>1. miggery sow was sent away from the castle but she was not sent away unkindly or cruelly</a:t>
+              <a:t>Mig left the castle kitchen, but she did not leave it in disgrace.</a:t>
             </a:r>
             <a:endParaRPr lang="en-US" sz="1700" dirty="0"/>
           </a:p>
@@ -6670,37 +7761,42 @@
       </p:sp>
       <p:sp>
         <p:nvSpPr>
-          <p:cNvPr id="7" name="Shape 5"/>
-          <p:cNvSpPr/>
-          <p:nvPr/>
-        </p:nvSpPr>
-        <p:spPr>
-          <a:xfrm>
-            <a:off x="365760" y="1874520"/>
-            <a:ext cx="8412480" cy="777240"/>
-          </a:xfrm>
-          <a:prstGeom prst="roundRect">
-            <a:avLst>
-              <a:gd name="adj" fmla="val 11765"/>
-            </a:avLst>
-          </a:prstGeom>
-          <a:solidFill>
-            <a:srgbClr val="FFFFFF"/>
-          </a:solidFill>
-          <a:ln w="19050">
-            <a:solidFill>
-              <a:srgbClr val="55C8E8"/>
-            </a:solidFill>
-            <a:prstDash val="solid"/>
-          </a:ln>
-          <a:effectLst>
-            <a:outerShdw sx="100000" sy="100000" kx="0" ky="0" algn="bl" rotWithShape="0" blurRad="101600" dist="38100" dir="2700000">
-              <a:srgbClr val="000000">
-                <a:alpha val="12000"/>
-              </a:srgbClr>
-            </a:outerShdw>
-          </a:effectLst>
-        </p:spPr>
+          <p:cNvPr id="7" name="Text 5"/>
+          <p:cNvSpPr/>
+          <p:nvPr/>
+        </p:nvSpPr>
+        <p:spPr>
+          <a:xfrm>
+            <a:off x="365760" y="2103120"/>
+            <a:ext cx="8229600" cy="237744"/>
+          </a:xfrm>
+          <a:prstGeom prst="rect">
+            <a:avLst/>
+          </a:prstGeom>
+          <a:noFill/>
+          <a:ln/>
+        </p:spPr>
+        <p:txBody>
+          <a:bodyPr wrap="square" lIns="0" tIns="0" rIns="0" bIns="0" rtlCol="0" anchor="ctr"/>
+          <a:lstStyle/>
+          <a:p>
+            <a:pPr indent="0" marL="0">
+              <a:buNone/>
+            </a:pPr>
+            <a:r>
+              <a:rPr lang="en-US" sz="1100" b="1" spc="100" kern="0" dirty="0">
+                <a:solidFill>
+                  <a:srgbClr val="55C8E8"/>
+                </a:solidFill>
+                <a:latin typeface="Calibri" pitchFamily="34" charset="0"/>
+                <a:ea typeface="Calibri" pitchFamily="34" charset="-122"/>
+                <a:cs typeface="Calibri" pitchFamily="34" charset="-120"/>
+              </a:rPr>
+              <a:t>NOTICE</a:t>
+            </a:r>
+            <a:endParaRPr lang="en-US" sz="1100" dirty="0"/>
+          </a:p>
+        </p:txBody>
       </p:sp>
       <p:sp>
         <p:nvSpPr>
@@ -6710,24 +7806,24 @@
         </p:nvSpPr>
         <p:spPr>
           <a:xfrm>
-            <a:off x="594360" y="2002536"/>
-            <a:ext cx="7955280" cy="521208"/>
-          </a:xfrm>
-          <a:prstGeom prst="rect">
-            <a:avLst/>
-          </a:prstGeom>
-          <a:noFill/>
-          <a:ln/>
-        </p:spPr>
-        <p:txBody>
-          <a:bodyPr wrap="square" lIns="0" tIns="0" rIns="0" bIns="0" rtlCol="0" anchor="ctr"/>
-          <a:lstStyle/>
-          <a:p>
-            <a:pPr indent="0" marL="0">
-              <a:buNone/>
-            </a:pPr>
-            <a:r>
-              <a:rPr lang="en-US" sz="1700" dirty="0">
+            <a:off x="365760" y="2359152"/>
+            <a:ext cx="8412480" cy="1097280"/>
+          </a:xfrm>
+          <a:prstGeom prst="rect">
+            <a:avLst/>
+          </a:prstGeom>
+          <a:noFill/>
+          <a:ln/>
+        </p:spPr>
+        <p:txBody>
+          <a:bodyPr wrap="square" lIns="0" tIns="0" rIns="0" bIns="0" rtlCol="0" anchor="t"/>
+          <a:lstStyle/>
+          <a:p>
+            <a:pPr indent="0" marL="0">
+              <a:buNone/>
+            </a:pPr>
+            <a:r>
+              <a:rPr lang="en-US" sz="1500" dirty="0">
                 <a:solidFill>
                   <a:srgbClr val="1E293B"/>
                 </a:solidFill>
@@ -6735,48 +7831,9 @@
                 <a:ea typeface="Calibri" pitchFamily="34" charset="-122"/>
                 <a:cs typeface="Calibri" pitchFamily="34" charset="-120"/>
               </a:rPr>
-              <a:t>2. the kingdom slowly and carefully began to feel like itself again with soup and light and stories</a:t>
-            </a:r>
-            <a:endParaRPr lang="en-US" sz="1700" dirty="0"/>
-          </a:p>
-        </p:txBody>
-      </p:sp>
-      <p:sp>
-        <p:nvSpPr>
-          <p:cNvPr id="9" name="Text 7"/>
-          <p:cNvSpPr/>
-          <p:nvPr/>
-        </p:nvSpPr>
-        <p:spPr>
-          <a:xfrm>
-            <a:off x="365760" y="2788920"/>
-            <a:ext cx="8412480" cy="365760"/>
-          </a:xfrm>
-          <a:prstGeom prst="rect">
-            <a:avLst/>
-          </a:prstGeom>
-          <a:noFill/>
-          <a:ln/>
-        </p:spPr>
-        <p:txBody>
-          <a:bodyPr wrap="square" lIns="0" tIns="0" rIns="0" bIns="0" rtlCol="0" anchor="ctr"/>
-          <a:lstStyle/>
-          <a:p>
-            <a:pPr indent="0" marL="0">
-              <a:buNone/>
-            </a:pPr>
-            <a:r>
-              <a:rPr lang="en-US" sz="1600" b="1" dirty="0">
-                <a:solidFill>
-                  <a:srgbClr val="0E1C42"/>
-                </a:solidFill>
-                <a:latin typeface="Calibri" pitchFamily="34" charset="0"/>
-                <a:ea typeface="Calibri" pitchFamily="34" charset="-122"/>
-                <a:cs typeface="Calibri" pitchFamily="34" charset="-120"/>
-              </a:rPr>
-              <a:t>Rewrite both sentences correctly in your notebook.</a:t>
-            </a:r>
-            <a:endParaRPr lang="en-US" sz="1600" dirty="0"/>
+              <a:t>a comma comes before but because it joins two complete sentences. Mig is a name and is capitalized. A period ends the sentence.</a:t>
+            </a:r>
+            <a:endParaRPr lang="en-US" sz="1500" dirty="0"/>
           </a:p>
         </p:txBody>
       </p:sp>
@@ -6904,7 +7961,7 @@
                 <a:ea typeface="Calibri" pitchFamily="34" charset="-122"/>
                 <a:cs typeface="Calibri" pitchFamily="34" charset="-120"/>
               </a:rPr>
-              <a:t>FIX THESE SENTENCES</a:t>
+              <a:t>NOW FIX THIS ONE</a:t>
             </a:r>
             <a:endParaRPr lang="en-US" sz="1100" dirty="0"/>
           </a:p>
@@ -6977,7 +8034,7 @@
                 <a:ea typeface="Calibri" pitchFamily="34" charset="-122"/>
                 <a:cs typeface="Calibri" pitchFamily="34" charset="-120"/>
               </a:rPr>
-              <a:t>1. miggery sow was sent away from the castle but she was not sent away unkindly or cruelly</a:t>
+              <a:t>miggery sow was sent away from the castle but she was not sent away unkindly or cruelly</a:t>
             </a:r>
             <a:endParaRPr lang="en-US" sz="1700" dirty="0"/>
           </a:p>
@@ -6985,226 +8042,40 @@
       </p:sp>
       <p:sp>
         <p:nvSpPr>
-          <p:cNvPr id="7" name="Shape 5"/>
-          <p:cNvSpPr/>
-          <p:nvPr/>
-        </p:nvSpPr>
-        <p:spPr>
-          <a:xfrm>
-            <a:off x="365760" y="1874520"/>
-            <a:ext cx="8412480" cy="777240"/>
-          </a:xfrm>
-          <a:prstGeom prst="roundRect">
-            <a:avLst>
-              <a:gd name="adj" fmla="val 11765"/>
-            </a:avLst>
-          </a:prstGeom>
-          <a:solidFill>
-            <a:srgbClr val="FFFFFF"/>
-          </a:solidFill>
-          <a:ln w="19050">
-            <a:solidFill>
-              <a:srgbClr val="55C8E8"/>
-            </a:solidFill>
-            <a:prstDash val="solid"/>
-          </a:ln>
-          <a:effectLst>
-            <a:outerShdw sx="100000" sy="100000" kx="0" ky="0" algn="bl" rotWithShape="0" blurRad="101600" dist="38100" dir="2700000">
-              <a:srgbClr val="000000">
-                <a:alpha val="12000"/>
-              </a:srgbClr>
-            </a:outerShdw>
-          </a:effectLst>
-        </p:spPr>
-      </p:sp>
-      <p:sp>
-        <p:nvSpPr>
-          <p:cNvPr id="8" name="Text 6"/>
-          <p:cNvSpPr/>
-          <p:nvPr/>
-        </p:nvSpPr>
-        <p:spPr>
-          <a:xfrm>
-            <a:off x="594360" y="2002536"/>
-            <a:ext cx="7955280" cy="521208"/>
-          </a:xfrm>
-          <a:prstGeom prst="rect">
-            <a:avLst/>
-          </a:prstGeom>
-          <a:noFill/>
-          <a:ln/>
-        </p:spPr>
-        <p:txBody>
-          <a:bodyPr wrap="square" lIns="0" tIns="0" rIns="0" bIns="0" rtlCol="0" anchor="ctr"/>
-          <a:lstStyle/>
-          <a:p>
-            <a:pPr indent="0" marL="0">
-              <a:buNone/>
-            </a:pPr>
-            <a:r>
-              <a:rPr lang="en-US" sz="1700" dirty="0">
-                <a:solidFill>
-                  <a:srgbClr val="1E293B"/>
-                </a:solidFill>
-                <a:latin typeface="Calibri" pitchFamily="34" charset="0"/>
-                <a:ea typeface="Calibri" pitchFamily="34" charset="-122"/>
-                <a:cs typeface="Calibri" pitchFamily="34" charset="-120"/>
-              </a:rPr>
-              <a:t>2. the kingdom slowly and carefully began to feel like itself again with soup and light and stories</a:t>
-            </a:r>
-            <a:endParaRPr lang="en-US" sz="1700" dirty="0"/>
-          </a:p>
-        </p:txBody>
-      </p:sp>
-      <p:sp>
-        <p:nvSpPr>
-          <p:cNvPr id="9" name="Shape 7"/>
-          <p:cNvSpPr/>
-          <p:nvPr/>
-        </p:nvSpPr>
-        <p:spPr>
-          <a:xfrm>
-            <a:off x="365760" y="2743200"/>
-            <a:ext cx="8412480" cy="1417320"/>
-          </a:xfrm>
-          <a:prstGeom prst="roundRect">
-            <a:avLst>
-              <a:gd name="adj" fmla="val 6452"/>
-            </a:avLst>
-          </a:prstGeom>
-          <a:solidFill>
-            <a:srgbClr val="E8F8EF"/>
-          </a:solidFill>
-          <a:ln/>
-          <a:effectLst>
-            <a:outerShdw sx="100000" sy="100000" kx="0" ky="0" algn="bl" rotWithShape="0" blurRad="101600" dist="38100" dir="2700000">
-              <a:srgbClr val="000000">
-                <a:alpha val="12000"/>
-              </a:srgbClr>
-            </a:outerShdw>
-          </a:effectLst>
-        </p:spPr>
-      </p:sp>
-      <p:sp>
-        <p:nvSpPr>
-          <p:cNvPr id="10" name="Text 8"/>
-          <p:cNvSpPr/>
-          <p:nvPr/>
-        </p:nvSpPr>
-        <p:spPr>
-          <a:xfrm>
-            <a:off x="566928" y="2816352"/>
-            <a:ext cx="8229600" cy="237744"/>
-          </a:xfrm>
-          <a:prstGeom prst="rect">
-            <a:avLst/>
-          </a:prstGeom>
-          <a:noFill/>
-          <a:ln/>
-        </p:spPr>
-        <p:txBody>
-          <a:bodyPr wrap="square" lIns="0" tIns="0" rIns="0" bIns="0" rtlCol="0" anchor="ctr"/>
-          <a:lstStyle/>
-          <a:p>
-            <a:pPr indent="0" marL="0">
-              <a:buNone/>
-            </a:pPr>
-            <a:r>
-              <a:rPr lang="en-US" sz="1100" b="1" spc="100" kern="0" dirty="0">
-                <a:solidFill>
-                  <a:srgbClr val="34B76F"/>
-                </a:solidFill>
-                <a:latin typeface="Calibri" pitchFamily="34" charset="0"/>
-                <a:ea typeface="Calibri" pitchFamily="34" charset="-122"/>
-                <a:cs typeface="Calibri" pitchFamily="34" charset="-120"/>
-              </a:rPr>
-              <a:t>✅  CORRECTED</a:t>
-            </a:r>
-            <a:endParaRPr lang="en-US" sz="1100" dirty="0"/>
-          </a:p>
-        </p:txBody>
-      </p:sp>
-      <p:sp>
-        <p:nvSpPr>
-          <p:cNvPr id="11" name="Text 9"/>
-          <p:cNvSpPr/>
-          <p:nvPr/>
-        </p:nvSpPr>
-        <p:spPr>
-          <a:xfrm>
-            <a:off x="566928" y="3072384"/>
-            <a:ext cx="8010144" cy="685800"/>
-          </a:xfrm>
-          <a:prstGeom prst="rect">
-            <a:avLst/>
-          </a:prstGeom>
-          <a:noFill/>
-          <a:ln/>
-        </p:spPr>
-        <p:txBody>
-          <a:bodyPr wrap="square" lIns="0" tIns="0" rIns="0" bIns="0" rtlCol="0" anchor="ctr"/>
-          <a:lstStyle/>
-          <a:p>
-            <a:pPr indent="0" marL="0">
-              <a:buNone/>
-            </a:pPr>
-            <a:endParaRPr lang="en-US" sz="1400" dirty="0"/>
-          </a:p>
-          <a:p>
-            <a:pPr indent="0" marL="0">
-              <a:buNone/>
-            </a:pPr>
-            <a:r>
-              <a:rPr lang="en-US" sz="1400" i="1" dirty="0">
-                <a:solidFill>
-                  <a:srgbClr val="1E293B"/>
-                </a:solidFill>
-                <a:latin typeface="Calibri" pitchFamily="34" charset="0"/>
-                <a:ea typeface="Calibri" pitchFamily="34" charset="-122"/>
-                <a:cs typeface="Calibri" pitchFamily="34" charset="-120"/>
-              </a:rPr>
-              <a:t>1. Miggery Sow was sent away from the castle , but she was not sent away unkindly or cruelly.</a:t>
-            </a:r>
-            <a:endParaRPr lang="en-US" sz="1400" dirty="0"/>
-          </a:p>
-        </p:txBody>
-      </p:sp>
-      <p:sp>
-        <p:nvSpPr>
-          <p:cNvPr id="12" name="Text 10"/>
-          <p:cNvSpPr/>
-          <p:nvPr/>
-        </p:nvSpPr>
-        <p:spPr>
-          <a:xfrm>
-            <a:off x="566928" y="3767328"/>
-            <a:ext cx="8010144" cy="320040"/>
-          </a:xfrm>
-          <a:prstGeom prst="rect">
-            <a:avLst/>
-          </a:prstGeom>
-          <a:noFill/>
-          <a:ln/>
-        </p:spPr>
-        <p:txBody>
-          <a:bodyPr wrap="square" lIns="0" tIns="0" rIns="0" bIns="0" rtlCol="0" anchor="ctr"/>
-          <a:lstStyle/>
-          <a:p>
-            <a:pPr indent="0" marL="0">
-              <a:buNone/>
-            </a:pPr>
-            <a:r>
-              <a:rPr lang="en-US" sz="1200" dirty="0">
-                <a:solidFill>
-                  <a:srgbClr val="64748B"/>
-                </a:solidFill>
-                <a:latin typeface="Calibri" pitchFamily="34" charset="0"/>
-                <a:ea typeface="Calibri" pitchFamily="34" charset="-122"/>
-                <a:cs typeface="Calibri" pitchFamily="34" charset="-120"/>
-              </a:rPr>
-              <a:t>Did you catch the proper nouns (Miggery Sow), the -ly adverbs (unkindly, cruelly, slowly, carefully), and the comma before "but"?</a:t>
-            </a:r>
-            <a:endParaRPr lang="en-US" sz="1200" dirty="0"/>
+          <p:cNvPr id="7" name="Text 5"/>
+          <p:cNvSpPr/>
+          <p:nvPr/>
+        </p:nvSpPr>
+        <p:spPr>
+          <a:xfrm>
+            <a:off x="365760" y="2788920"/>
+            <a:ext cx="8412480" cy="365760"/>
+          </a:xfrm>
+          <a:prstGeom prst="rect">
+            <a:avLst/>
+          </a:prstGeom>
+          <a:noFill/>
+          <a:ln/>
+        </p:spPr>
+        <p:txBody>
+          <a:bodyPr wrap="square" lIns="0" tIns="0" rIns="0" bIns="0" rtlCol="0" anchor="ctr"/>
+          <a:lstStyle/>
+          <a:p>
+            <a:pPr indent="0" marL="0">
+              <a:buNone/>
+            </a:pPr>
+            <a:r>
+              <a:rPr lang="en-US" sz="1600" b="1" dirty="0">
+                <a:solidFill>
+                  <a:srgbClr val="0E1C42"/>
+                </a:solidFill>
+                <a:latin typeface="Calibri" pitchFamily="34" charset="0"/>
+                <a:ea typeface="Calibri" pitchFamily="34" charset="-122"/>
+                <a:cs typeface="Calibri" pitchFamily="34" charset="-120"/>
+              </a:rPr>
+              <a:t>Rewrite the sentence correctly in your notebook.</a:t>
+            </a:r>
+            <a:endParaRPr lang="en-US" sz="1600" dirty="0"/>
           </a:p>
         </p:txBody>
       </p:sp>
@@ -7222,7 +8093,7 @@
     <p:bg>
       <p:bgPr>
         <a:solidFill>
-          <a:srgbClr val="FFFFFF"/>
+          <a:srgbClr val="F8FAFC"/>
         </a:solidFill>
       </p:bgPr>
     </p:bg>
@@ -7255,7 +8126,7 @@
             <a:avLst/>
           </a:prstGeom>
           <a:solidFill>
-            <a:srgbClr val="8B6FC0"/>
+            <a:srgbClr val="55C8E8"/>
           </a:solidFill>
           <a:ln/>
         </p:spPr>
@@ -7293,7 +8164,7 @@
                 <a:ea typeface="Calibri" pitchFamily="34" charset="-122"/>
                 <a:cs typeface="Calibri" pitchFamily="34" charset="-120"/>
               </a:rPr>
-              <a:t>🌱  Morphology</a:t>
+              <a:t>✏️  Daily Oral Language</a:t>
             </a:r>
             <a:endParaRPr lang="en-US" sz="2200" dirty="0"/>
           </a:p>
@@ -7307,7 +8178,7 @@
         </p:nvSpPr>
         <p:spPr>
           <a:xfrm>
-            <a:off x="365760" y="804672"/>
+            <a:off x="365760" y="749808"/>
             <a:ext cx="8229600" cy="237744"/>
           </a:xfrm>
           <a:prstGeom prst="rect">
@@ -7326,13 +8197,13 @@
             <a:r>
               <a:rPr lang="en-US" sz="1100" b="1" spc="100" kern="0" dirty="0">
                 <a:solidFill>
-                  <a:srgbClr val="8B6FC0"/>
-                </a:solidFill>
-                <a:latin typeface="Calibri" pitchFamily="34" charset="0"/>
-                <a:ea typeface="Calibri" pitchFamily="34" charset="-122"/>
-                <a:cs typeface="Calibri" pitchFamily="34" charset="-120"/>
-              </a:rPr>
-              <a:t>-TION</a:t>
+                  <a:srgbClr val="55C8E8"/>
+                </a:solidFill>
+                <a:latin typeface="Calibri" pitchFamily="34" charset="0"/>
+                <a:ea typeface="Calibri" pitchFamily="34" charset="-122"/>
+                <a:cs typeface="Calibri" pitchFamily="34" charset="-120"/>
+              </a:rPr>
+              <a:t>NOW FIX THIS ONE</a:t>
             </a:r>
             <a:endParaRPr lang="en-US" sz="1100" dirty="0"/>
           </a:p>
@@ -7346,18 +8217,23 @@
         </p:nvSpPr>
         <p:spPr>
           <a:xfrm>
-            <a:off x="365760" y="1097280"/>
-            <a:ext cx="8412480" cy="621792"/>
+            <a:off x="365760" y="1024128"/>
+            <a:ext cx="8412480" cy="777240"/>
           </a:xfrm>
           <a:prstGeom prst="roundRect">
             <a:avLst>
-              <a:gd name="adj" fmla="val 14706"/>
+              <a:gd name="adj" fmla="val 11765"/>
             </a:avLst>
           </a:prstGeom>
           <a:solidFill>
-            <a:srgbClr val="F0E8FF"/>
+            <a:srgbClr val="FFFFFF"/>
           </a:solidFill>
-          <a:ln/>
+          <a:ln w="19050">
+            <a:solidFill>
+              <a:srgbClr val="55C8E8"/>
+            </a:solidFill>
+            <a:prstDash val="solid"/>
+          </a:ln>
           <a:effectLst>
             <a:outerShdw sx="100000" sy="100000" kx="0" ky="0" algn="bl" rotWithShape="0" blurRad="101600" dist="38100" dir="2700000">
               <a:srgbClr val="000000">
@@ -7375,24 +8251,24 @@
         </p:nvSpPr>
         <p:spPr>
           <a:xfrm>
-            <a:off x="594360" y="1216152"/>
-            <a:ext cx="7863840" cy="384048"/>
-          </a:xfrm>
-          <a:prstGeom prst="rect">
-            <a:avLst/>
-          </a:prstGeom>
-          <a:noFill/>
-          <a:ln/>
-        </p:spPr>
-        <p:txBody>
-          <a:bodyPr wrap="square" lIns="0" tIns="0" rIns="0" bIns="0" rtlCol="0" anchor="ctr"/>
-          <a:lstStyle/>
-          <a:p>
-            <a:pPr indent="0" marL="0">
-              <a:buNone/>
-            </a:pPr>
-            <a:r>
-              <a:rPr lang="en-US" sz="1500" dirty="0">
+            <a:off x="594360" y="1152144"/>
+            <a:ext cx="7955280" cy="521208"/>
+          </a:xfrm>
+          <a:prstGeom prst="rect">
+            <a:avLst/>
+          </a:prstGeom>
+          <a:noFill/>
+          <a:ln/>
+        </p:spPr>
+        <p:txBody>
+          <a:bodyPr wrap="square" lIns="0" tIns="0" rIns="0" bIns="0" rtlCol="0" anchor="ctr"/>
+          <a:lstStyle/>
+          <a:p>
+            <a:pPr indent="0" marL="0">
+              <a:buNone/>
+            </a:pPr>
+            <a:r>
+              <a:rPr lang="en-US" sz="1700" dirty="0">
                 <a:solidFill>
                   <a:srgbClr val="1E293B"/>
                 </a:solidFill>
@@ -7400,9 +8276,9 @@
                 <a:ea typeface="Calibri" pitchFamily="34" charset="-122"/>
                 <a:cs typeface="Calibri" pitchFamily="34" charset="-120"/>
               </a:rPr>
-              <a:t>🌱  action — base word act = the act of doing</a:t>
-            </a:r>
-            <a:endParaRPr lang="en-US" sz="1500" dirty="0"/>
+              <a:t>miggery sow was sent away from the castle but she was not sent away unkindly or cruelly</a:t>
+            </a:r>
+            <a:endParaRPr lang="en-US" sz="1700" dirty="0"/>
           </a:p>
         </p:txBody>
       </p:sp>
@@ -7414,16 +8290,16 @@
         </p:nvSpPr>
         <p:spPr>
           <a:xfrm>
-            <a:off x="365760" y="1792224"/>
-            <a:ext cx="8412480" cy="621792"/>
+            <a:off x="365760" y="2743200"/>
+            <a:ext cx="8412480" cy="1417320"/>
           </a:xfrm>
           <a:prstGeom prst="roundRect">
             <a:avLst>
-              <a:gd name="adj" fmla="val 14706"/>
+              <a:gd name="adj" fmla="val 6452"/>
             </a:avLst>
           </a:prstGeom>
           <a:solidFill>
-            <a:srgbClr val="F8F4FF"/>
+            <a:srgbClr val="E8F8EF"/>
           </a:solidFill>
           <a:ln/>
           <a:effectLst>
@@ -7443,24 +8319,63 @@
         </p:nvSpPr>
         <p:spPr>
           <a:xfrm>
-            <a:off x="594360" y="1911096"/>
-            <a:ext cx="7863840" cy="384048"/>
-          </a:xfrm>
-          <a:prstGeom prst="rect">
-            <a:avLst/>
-          </a:prstGeom>
-          <a:noFill/>
-          <a:ln/>
-        </p:spPr>
-        <p:txBody>
-          <a:bodyPr wrap="square" lIns="0" tIns="0" rIns="0" bIns="0" rtlCol="0" anchor="ctr"/>
-          <a:lstStyle/>
-          <a:p>
-            <a:pPr indent="0" marL="0">
-              <a:buNone/>
-            </a:pPr>
-            <a:r>
-              <a:rPr lang="en-US" sz="1500" dirty="0">
+            <a:off x="566928" y="2816352"/>
+            <a:ext cx="8229600" cy="237744"/>
+          </a:xfrm>
+          <a:prstGeom prst="rect">
+            <a:avLst/>
+          </a:prstGeom>
+          <a:noFill/>
+          <a:ln/>
+        </p:spPr>
+        <p:txBody>
+          <a:bodyPr wrap="square" lIns="0" tIns="0" rIns="0" bIns="0" rtlCol="0" anchor="ctr"/>
+          <a:lstStyle/>
+          <a:p>
+            <a:pPr indent="0" marL="0">
+              <a:buNone/>
+            </a:pPr>
+            <a:r>
+              <a:rPr lang="en-US" sz="1100" b="1" spc="100" kern="0" dirty="0">
+                <a:solidFill>
+                  <a:srgbClr val="34B76F"/>
+                </a:solidFill>
+                <a:latin typeface="Calibri" pitchFamily="34" charset="0"/>
+                <a:ea typeface="Calibri" pitchFamily="34" charset="-122"/>
+                <a:cs typeface="Calibri" pitchFamily="34" charset="-120"/>
+              </a:rPr>
+              <a:t>✅  CORRECTED</a:t>
+            </a:r>
+            <a:endParaRPr lang="en-US" sz="1100" dirty="0"/>
+          </a:p>
+        </p:txBody>
+      </p:sp>
+      <p:sp>
+        <p:nvSpPr>
+          <p:cNvPr id="9" name="Text 7"/>
+          <p:cNvSpPr/>
+          <p:nvPr/>
+        </p:nvSpPr>
+        <p:spPr>
+          <a:xfrm>
+            <a:off x="566928" y="3072384"/>
+            <a:ext cx="8010144" cy="685800"/>
+          </a:xfrm>
+          <a:prstGeom prst="rect">
+            <a:avLst/>
+          </a:prstGeom>
+          <a:noFill/>
+          <a:ln/>
+        </p:spPr>
+        <p:txBody>
+          <a:bodyPr wrap="square" lIns="0" tIns="0" rIns="0" bIns="0" rtlCol="0" anchor="ctr"/>
+          <a:lstStyle/>
+          <a:p>
+            <a:pPr indent="0" marL="0">
+              <a:buNone/>
+            </a:pPr>
+            <a:r>
+              <a:rPr lang="en-US" sz="1400" i="1" dirty="0">
                 <a:solidFill>
                   <a:srgbClr val="1E293B"/>
                 </a:solidFill>
@@ -7468,145 +8383,15 @@
                 <a:ea typeface="Calibri" pitchFamily="34" charset="-122"/>
                 <a:cs typeface="Calibri" pitchFamily="34" charset="-120"/>
               </a:rPr>
-              <a:t>🌱  direction — base word direct = the way something is aimed</a:t>
-            </a:r>
-            <a:endParaRPr lang="en-US" sz="1500" dirty="0"/>
-          </a:p>
-        </p:txBody>
-      </p:sp>
-      <p:sp>
-        <p:nvSpPr>
-          <p:cNvPr id="9" name="Shape 7"/>
-          <p:cNvSpPr/>
-          <p:nvPr/>
-        </p:nvSpPr>
-        <p:spPr>
-          <a:xfrm>
-            <a:off x="365760" y="2487168"/>
-            <a:ext cx="8412480" cy="621792"/>
-          </a:xfrm>
-          <a:prstGeom prst="roundRect">
-            <a:avLst>
-              <a:gd name="adj" fmla="val 14706"/>
-            </a:avLst>
-          </a:prstGeom>
-          <a:solidFill>
-            <a:srgbClr val="F0E8FF"/>
-          </a:solidFill>
-          <a:ln/>
-          <a:effectLst>
-            <a:outerShdw sx="100000" sy="100000" kx="0" ky="0" algn="bl" rotWithShape="0" blurRad="101600" dist="38100" dir="2700000">
-              <a:srgbClr val="000000">
-                <a:alpha val="12000"/>
-              </a:srgbClr>
-            </a:outerShdw>
-          </a:effectLst>
-        </p:spPr>
-      </p:sp>
-      <p:sp>
-        <p:nvSpPr>
-          <p:cNvPr id="10" name="Text 8"/>
-          <p:cNvSpPr/>
-          <p:nvPr/>
-        </p:nvSpPr>
-        <p:spPr>
-          <a:xfrm>
-            <a:off x="594360" y="2606040"/>
-            <a:ext cx="7863840" cy="384048"/>
-          </a:xfrm>
-          <a:prstGeom prst="rect">
-            <a:avLst/>
-          </a:prstGeom>
-          <a:noFill/>
-          <a:ln/>
-        </p:spPr>
-        <p:txBody>
-          <a:bodyPr wrap="square" lIns="0" tIns="0" rIns="0" bIns="0" rtlCol="0" anchor="ctr"/>
-          <a:lstStyle/>
-          <a:p>
-            <a:pPr indent="0" marL="0">
-              <a:buNone/>
-            </a:pPr>
-            <a:r>
-              <a:rPr lang="en-US" sz="1500" dirty="0">
-                <a:solidFill>
-                  <a:srgbClr val="1E293B"/>
-                </a:solidFill>
-                <a:latin typeface="Calibri" pitchFamily="34" charset="0"/>
-                <a:ea typeface="Calibri" pitchFamily="34" charset="-122"/>
-                <a:cs typeface="Calibri" pitchFamily="34" charset="-120"/>
-              </a:rPr>
-              <a:t>🌱  attention — base word attend = careful noticing</a:t>
-            </a:r>
-            <a:endParaRPr lang="en-US" sz="1500" dirty="0"/>
-          </a:p>
-        </p:txBody>
-      </p:sp>
-      <p:sp>
-        <p:nvSpPr>
-          <p:cNvPr id="11" name="Shape 9"/>
-          <p:cNvSpPr/>
-          <p:nvPr/>
-        </p:nvSpPr>
-        <p:spPr>
-          <a:xfrm>
-            <a:off x="365760" y="3182112"/>
-            <a:ext cx="8412480" cy="621792"/>
-          </a:xfrm>
-          <a:prstGeom prst="roundRect">
-            <a:avLst>
-              <a:gd name="adj" fmla="val 14706"/>
-            </a:avLst>
-          </a:prstGeom>
-          <a:solidFill>
-            <a:srgbClr val="F8F4FF"/>
-          </a:solidFill>
-          <a:ln/>
-          <a:effectLst>
-            <a:outerShdw sx="100000" sy="100000" kx="0" ky="0" algn="bl" rotWithShape="0" blurRad="101600" dist="38100" dir="2700000">
-              <a:srgbClr val="000000">
-                <a:alpha val="12000"/>
-              </a:srgbClr>
-            </a:outerShdw>
-          </a:effectLst>
-        </p:spPr>
-      </p:sp>
-      <p:sp>
-        <p:nvSpPr>
-          <p:cNvPr id="12" name="Text 10"/>
-          <p:cNvSpPr/>
-          <p:nvPr/>
-        </p:nvSpPr>
-        <p:spPr>
-          <a:xfrm>
-            <a:off x="594360" y="3300984"/>
-            <a:ext cx="7863840" cy="384048"/>
-          </a:xfrm>
-          <a:prstGeom prst="rect">
-            <a:avLst/>
-          </a:prstGeom>
-          <a:noFill/>
-          <a:ln/>
-        </p:spPr>
-        <p:txBody>
-          <a:bodyPr wrap="square" lIns="0" tIns="0" rIns="0" bIns="0" rtlCol="0" anchor="ctr"/>
-          <a:lstStyle/>
-          <a:p>
-            <a:pPr indent="0" marL="0">
-              <a:buNone/>
-            </a:pPr>
-            <a:r>
-              <a:rPr lang="en-US" sz="1500" dirty="0">
-                <a:solidFill>
-                  <a:srgbClr val="1E293B"/>
-                </a:solidFill>
-                <a:latin typeface="Calibri" pitchFamily="34" charset="0"/>
-                <a:ea typeface="Calibri" pitchFamily="34" charset="-122"/>
-                <a:cs typeface="Calibri" pitchFamily="34" charset="-120"/>
-              </a:rPr>
-              <a:t>🌱  celebration — base word celebrate = the act of celebrating</a:t>
-            </a:r>
-            <a:endParaRPr lang="en-US" sz="1500" dirty="0"/>
+              <a:t>Miggery Sow was sent away from the castle, but she was not sent away unkindly or cruelly.</a:t>
+            </a:r>
+            <a:endParaRPr lang="en-US" sz="1400" dirty="0"/>
+          </a:p>
+          <a:p>
+            <a:pPr indent="0" marL="0">
+              <a:buNone/>
+            </a:pPr>
+            <a:endParaRPr lang="en-US" sz="1400" dirty="0"/>
           </a:p>
         </p:txBody>
       </p:sp>

</xml_diff>